<commit_message>
Refine: Add generated Focus Media logo and 3D illustration, streamline structure
</commit_message>
<xml_diff>
--- a/Focus_Media_Toshkent_Viloyati_5_Slayd.pptx
+++ b/Focus_Media_Toshkent_Viloyati_5_Slayd.pptx
@@ -3143,8 +3143,8 @@
         </p:nvSpPr>
         <p:spPr>
           <a:xfrm>
-            <a:off x="731520" y="502920"/>
-            <a:ext cx="5303520" cy="320040"/>
+            <a:off x="731520" y="548640"/>
+            <a:ext cx="2560320" cy="292608"/>
           </a:xfrm>
           <a:prstGeom prst="roundRect">
             <a:avLst/>
@@ -3173,18 +3173,18 @@
           </a:fontRef>
         </p:style>
         <p:txBody>
-          <a:bodyPr rtlCol="0" anchor="ctr" lIns="137160" tIns="0" bIns="0" rIns="0"/>
+          <a:bodyPr rtlCol="0" anchor="ctr" lIns="109728" tIns="0" bIns="0" rIns="0"/>
           <a:lstStyle/>
           <a:p>
             <a:pPr algn="ctr"/>
             <a:r>
               <a:rPr sz="900" b="1">
                 <a:solidFill>
-                  <a:srgbClr val="1E3A8A"/>
-                </a:solidFill>
-                <a:latin typeface="Arial"/>
-              </a:rPr>
-              <a:t>TOSHKENT VILOYATI HOKIMLIGI  |  MAKTAB TA’LIMI BOSHQARMASI</a:t>
+                  <a:srgbClr val="2563EB"/>
+                </a:solidFill>
+                <a:latin typeface="Arial"/>
+              </a:rPr>
+              <a:t>LOYIHA TAQDIMOTI</a:t>
             </a:r>
           </a:p>
         </p:txBody>
@@ -3197,8 +3197,8 @@
         </p:nvSpPr>
         <p:spPr>
           <a:xfrm>
-            <a:off x="731520" y="1005840"/>
-            <a:ext cx="10728655" cy="1005840"/>
+            <a:off x="731520" y="960120"/>
+            <a:ext cx="8046720" cy="1051560"/>
           </a:xfrm>
           <a:prstGeom prst="rect">
             <a:avLst/>
@@ -3221,29 +3221,30 @@
               <a:t>«FOCUS MEDIA»</a:t>
             </a:r>
             <a:r>
-              <a:rPr sz="2200" b="1">
+              <a:rPr sz="1600" b="1">
                 <a:solidFill>
                   <a:srgbClr val="2563EB"/>
                 </a:solidFill>
                 <a:latin typeface="Arial"/>
               </a:rPr>
-              <a:t> — Toshkent Viloyati Umumta’lim Maktablari Yagona Raqamli Tizimi</a:t>
+              <a:t>
+Toshkent viloyati umumta’lim muassasalarining yagona raqamli tizimi</a:t>
             </a:r>
           </a:p>
           <a:p>
             <a:pPr>
               <a:spcBef>
-                <a:spcPts val="600"/>
+                <a:spcPts val="400"/>
               </a:spcBef>
             </a:pPr>
             <a:r>
-              <a:rPr sz="1100">
+              <a:rPr sz="1050">
                 <a:solidFill>
                   <a:srgbClr val="64748B"/>
                 </a:solidFill>
                 <a:latin typeface="Arial"/>
               </a:rPr>
-              <a:t>Viloyat ta’lim tizimida axborot boshqaruvi, ochiqlik, media-savodxonlik va yoshlar iqtidorini yagona tizimga birlashtiruvchi loyiha.</a:t>
+              <a:t>Axborot boshqaruvi, tezkor ochiqlik va yoshlar intellektual salohiyatini yagona tizimga birlashtiruvchi loyiha.</a:t>
             </a:r>
           </a:p>
         </p:txBody>
@@ -3256,8 +3257,77 @@
         </p:nvSpPr>
         <p:spPr>
           <a:xfrm>
-            <a:off x="731520" y="2148840"/>
-            <a:ext cx="10728655" cy="1188720"/>
+            <a:off x="9144000" y="502920"/>
+            <a:ext cx="2316175" cy="2316175"/>
+          </a:xfrm>
+          <a:prstGeom prst="roundRect">
+            <a:avLst/>
+          </a:prstGeom>
+          <a:solidFill>
+            <a:srgbClr val="FFFFFF"/>
+          </a:solidFill>
+          <a:ln w="12700">
+            <a:solidFill>
+              <a:srgbClr val="E2E8F0"/>
+            </a:solidFill>
+          </a:ln>
+        </p:spPr>
+        <p:style>
+          <a:lnRef idx="1">
+            <a:schemeClr val="accent1"/>
+          </a:lnRef>
+          <a:fillRef idx="3">
+            <a:schemeClr val="accent1"/>
+          </a:fillRef>
+          <a:effectRef idx="2">
+            <a:schemeClr val="accent1"/>
+          </a:effectRef>
+          <a:fontRef idx="minor">
+            <a:schemeClr val="lt1"/>
+          </a:fontRef>
+        </p:style>
+        <p:txBody>
+          <a:bodyPr rtlCol="0" anchor="ctr"/>
+          <a:lstStyle/>
+          <a:p>
+            <a:pPr algn="ctr"/>
+          </a:p>
+        </p:txBody>
+      </p:sp>
+      <p:pic>
+        <p:nvPicPr>
+          <p:cNvPr id="6" name="Picture 5" descr="logo.jpg"/>
+          <p:cNvPicPr>
+            <a:picLocks noChangeAspect="1"/>
+          </p:cNvPicPr>
+          <p:nvPr/>
+        </p:nvPicPr>
+        <p:blipFill>
+          <a:blip r:embed="rId2"/>
+          <a:stretch>
+            <a:fillRect/>
+          </a:stretch>
+        </p:blipFill>
+        <p:spPr>
+          <a:xfrm>
+            <a:off x="9253728" y="612648"/>
+            <a:ext cx="2093976" cy="2093976"/>
+          </a:xfrm>
+          <a:prstGeom prst="rect">
+            <a:avLst/>
+          </a:prstGeom>
+        </p:spPr>
+      </p:pic>
+      <p:sp>
+        <p:nvSpPr>
+          <p:cNvPr id="7" name="Rounded Rectangle 6"/>
+          <p:cNvSpPr/>
+          <p:nvPr/>
+        </p:nvSpPr>
+        <p:spPr>
+          <a:xfrm>
+            <a:off x="731520" y="2194560"/>
+            <a:ext cx="8046720" cy="1143000"/>
           </a:xfrm>
           <a:prstGeom prst="roundRect">
             <a:avLst/>
@@ -3286,12 +3356,12 @@
           </a:fontRef>
         </p:style>
         <p:txBody>
-          <a:bodyPr rtlCol="0" anchor="ctr" wrap="square" lIns="320040" tIns="164592" rIns="274320" bIns="137160"/>
+          <a:bodyPr rtlCol="0" anchor="ctr" wrap="square" lIns="274320" tIns="137160" rIns="228600" bIns="109728"/>
           <a:lstStyle/>
           <a:p>
             <a:pPr algn="ctr"/>
             <a:r>
-              <a:rPr sz="950" b="1">
+              <a:rPr sz="900" b="1">
                 <a:solidFill>
                   <a:srgbClr val="2563EB"/>
                 </a:solidFill>
@@ -3303,11 +3373,11 @@
           <a:p>
             <a:pPr>
               <a:spcBef>
-                <a:spcPts val="400"/>
+                <a:spcPts val="300"/>
               </a:spcBef>
             </a:pPr>
             <a:r>
-              <a:rPr sz="1300" b="1">
+              <a:rPr sz="1200" b="1">
                 <a:solidFill>
                   <a:srgbClr val="0F172A"/>
                 </a:solidFill>
@@ -3320,14 +3390,14 @@
       </p:sp>
       <p:sp>
         <p:nvSpPr>
-          <p:cNvPr id="6" name="Rectangle 5"/>
+          <p:cNvPr id="8" name="Rectangle 7"/>
           <p:cNvSpPr/>
           <p:nvPr/>
         </p:nvSpPr>
         <p:spPr>
           <a:xfrm>
-            <a:off x="731520" y="2148840"/>
-            <a:ext cx="109728" cy="1188720"/>
+            <a:off x="731520" y="2194560"/>
+            <a:ext cx="91440" cy="1143000"/>
           </a:xfrm>
           <a:prstGeom prst="rect">
             <a:avLst/>
@@ -3363,7 +3433,7 @@
       </p:sp>
       <p:sp>
         <p:nvSpPr>
-          <p:cNvPr id="7" name="Rounded Rectangle 6"/>
+          <p:cNvPr id="9" name="Rounded Rectangle 8"/>
           <p:cNvSpPr/>
           <p:nvPr/>
         </p:nvSpPr>
@@ -3399,7 +3469,7 @@
           </a:fontRef>
         </p:style>
         <p:txBody>
-          <a:bodyPr rtlCol="0" anchor="ctr" wrap="square" lIns="164592" tIns="182880" rIns="164592" bIns="137160"/>
+          <a:bodyPr rtlCol="0" anchor="ctr" wrap="square" lIns="164592" tIns="164592" rIns="164592" bIns="109728"/>
           <a:lstStyle/>
           <a:p>
             <a:pPr algn="ctr"/>
@@ -3416,7 +3486,7 @@
           <a:p>
             <a:pPr>
               <a:spcBef>
-                <a:spcPts val="600"/>
+                <a:spcPts val="500"/>
               </a:spcBef>
             </a:pPr>
             <a:r>
@@ -3449,7 +3519,7 @@
       </p:sp>
       <p:sp>
         <p:nvSpPr>
-          <p:cNvPr id="8" name="Rectangle 7"/>
+          <p:cNvPr id="10" name="Rectangle 9"/>
           <p:cNvSpPr/>
           <p:nvPr/>
         </p:nvSpPr>
@@ -3492,7 +3562,7 @@
       </p:sp>
       <p:sp>
         <p:nvSpPr>
-          <p:cNvPr id="9" name="Rounded Rectangle 8"/>
+          <p:cNvPr id="11" name="Rounded Rectangle 10"/>
           <p:cNvSpPr/>
           <p:nvPr/>
         </p:nvSpPr>
@@ -3528,7 +3598,7 @@
           </a:fontRef>
         </p:style>
         <p:txBody>
-          <a:bodyPr rtlCol="0" anchor="ctr" wrap="square" lIns="164592" tIns="182880" rIns="164592" bIns="137160"/>
+          <a:bodyPr rtlCol="0" anchor="ctr" wrap="square" lIns="164592" tIns="164592" rIns="164592" bIns="109728"/>
           <a:lstStyle/>
           <a:p>
             <a:pPr algn="ctr"/>
@@ -3545,7 +3615,7 @@
           <a:p>
             <a:pPr>
               <a:spcBef>
-                <a:spcPts val="600"/>
+                <a:spcPts val="500"/>
               </a:spcBef>
             </a:pPr>
             <a:r>
@@ -3578,7 +3648,7 @@
       </p:sp>
       <p:sp>
         <p:nvSpPr>
-          <p:cNvPr id="10" name="Rectangle 9"/>
+          <p:cNvPr id="12" name="Rectangle 11"/>
           <p:cNvSpPr/>
           <p:nvPr/>
         </p:nvSpPr>
@@ -3621,7 +3691,7 @@
       </p:sp>
       <p:sp>
         <p:nvSpPr>
-          <p:cNvPr id="11" name="Rounded Rectangle 10"/>
+          <p:cNvPr id="13" name="Rounded Rectangle 12"/>
           <p:cNvSpPr/>
           <p:nvPr/>
         </p:nvSpPr>
@@ -3657,7 +3727,7 @@
           </a:fontRef>
         </p:style>
         <p:txBody>
-          <a:bodyPr rtlCol="0" anchor="ctr" wrap="square" lIns="164592" tIns="182880" rIns="164592" bIns="137160"/>
+          <a:bodyPr rtlCol="0" anchor="ctr" wrap="square" lIns="164592" tIns="164592" rIns="164592" bIns="109728"/>
           <a:lstStyle/>
           <a:p>
             <a:pPr algn="ctr"/>
@@ -3674,7 +3744,7 @@
           <a:p>
             <a:pPr>
               <a:spcBef>
-                <a:spcPts val="600"/>
+                <a:spcPts val="500"/>
               </a:spcBef>
             </a:pPr>
             <a:r>
@@ -3707,7 +3777,7 @@
       </p:sp>
       <p:sp>
         <p:nvSpPr>
-          <p:cNvPr id="12" name="Rectangle 11"/>
+          <p:cNvPr id="14" name="Rectangle 13"/>
           <p:cNvSpPr/>
           <p:nvPr/>
         </p:nvSpPr>
@@ -3750,7 +3820,7 @@
       </p:sp>
       <p:sp>
         <p:nvSpPr>
-          <p:cNvPr id="13" name="Rounded Rectangle 12"/>
+          <p:cNvPr id="15" name="Rounded Rectangle 14"/>
           <p:cNvSpPr/>
           <p:nvPr/>
         </p:nvSpPr>
@@ -3786,7 +3856,7 @@
           </a:fontRef>
         </p:style>
         <p:txBody>
-          <a:bodyPr rtlCol="0" anchor="ctr" wrap="square" lIns="164592" tIns="182880" rIns="164592" bIns="137160"/>
+          <a:bodyPr rtlCol="0" anchor="ctr" wrap="square" lIns="164592" tIns="164592" rIns="164592" bIns="109728"/>
           <a:lstStyle/>
           <a:p>
             <a:pPr algn="ctr"/>
@@ -3803,7 +3873,7 @@
           <a:p>
             <a:pPr>
               <a:spcBef>
-                <a:spcPts val="600"/>
+                <a:spcPts val="500"/>
               </a:spcBef>
             </a:pPr>
             <a:r>
@@ -3836,7 +3906,7 @@
       </p:sp>
       <p:sp>
         <p:nvSpPr>
-          <p:cNvPr id="14" name="Rectangle 13"/>
+          <p:cNvPr id="16" name="Rectangle 15"/>
           <p:cNvSpPr/>
           <p:nvPr/>
         </p:nvSpPr>
@@ -3879,14 +3949,14 @@
       </p:sp>
       <p:sp>
         <p:nvSpPr>
-          <p:cNvPr id="15" name="Rounded Rectangle 14"/>
+          <p:cNvPr id="17" name="Rounded Rectangle 16"/>
           <p:cNvSpPr/>
           <p:nvPr/>
         </p:nvSpPr>
         <p:spPr>
           <a:xfrm>
             <a:off x="731520" y="5440680"/>
-            <a:ext cx="10728655" cy="685800"/>
+            <a:ext cx="10728655" cy="658368"/>
           </a:xfrm>
           <a:prstGeom prst="roundRect">
             <a:avLst/>
@@ -3915,12 +3985,12 @@
           </a:fontRef>
         </p:style>
         <p:txBody>
-          <a:bodyPr rtlCol="0" anchor="ctr" wrap="square" lIns="228600" tIns="109728" rIns="228600" bIns="91440"/>
+          <a:bodyPr rtlCol="0" anchor="ctr" wrap="square" lIns="228600" tIns="137160" rIns="228600" bIns="91440"/>
           <a:lstStyle/>
           <a:p>
             <a:pPr algn="ctr"/>
             <a:r>
-              <a:rPr sz="1000">
+              <a:rPr sz="950">
                 <a:solidFill>
                   <a:srgbClr val="64748B"/>
                 </a:solidFill>
@@ -3929,7 +3999,7 @@
               <a:t>Loyiha Tashabbuskori: </a:t>
             </a:r>
             <a:r>
-              <a:rPr sz="1000" b="1">
+              <a:rPr sz="950" b="1">
                 <a:solidFill>
                   <a:srgbClr val="0F172A"/>
                 </a:solidFill>
@@ -3938,7 +4008,7 @@
               <a:t>To‘rabek Abduvoitov</a:t>
             </a:r>
             <a:r>
-              <a:rPr sz="1000">
+              <a:rPr sz="950">
                 <a:solidFill>
                   <a:srgbClr val="64748B"/>
                 </a:solidFill>
@@ -3947,7 +4017,7 @@
               <a:t>   |   Telegram: </a:t>
             </a:r>
             <a:r>
-              <a:rPr sz="1000" b="1">
+              <a:rPr sz="950" b="1">
                 <a:solidFill>
                   <a:srgbClr val="2563EB"/>
                 </a:solidFill>
@@ -3956,16 +4026,16 @@
               <a:t>@Torabek_Abduvoitov</a:t>
             </a:r>
             <a:r>
-              <a:rPr sz="1000">
+              <a:rPr sz="950">
                 <a:solidFill>
                   <a:srgbClr val="64748B"/>
                 </a:solidFill>
                 <a:latin typeface="Arial"/>
               </a:rPr>
-              <a:t>   |   Rasmiy Bot: </a:t>
-            </a:r>
-            <a:r>
-              <a:rPr sz="1000" b="1">
+              <a:t>   |   Bot: </a:t>
+            </a:r>
+            <a:r>
+              <a:rPr sz="950" b="1">
                 <a:solidFill>
                   <a:srgbClr val="1E3A8A"/>
                 </a:solidFill>
@@ -3974,16 +4044,16 @@
               <a:t>@focusmedia4_bot</a:t>
             </a:r>
             <a:r>
-              <a:rPr sz="1000">
+              <a:rPr sz="950">
                 <a:solidFill>
                   <a:srgbClr val="64748B"/>
                 </a:solidFill>
                 <a:latin typeface="Arial"/>
               </a:rPr>
-              <a:t>   |   Elektron Portal: </a:t>
-            </a:r>
-            <a:r>
-              <a:rPr sz="1000" b="1">
+              <a:t>   |   Portal: </a:t>
+            </a:r>
+            <a:r>
+              <a:rPr sz="950" b="1">
                 <a:solidFill>
                   <a:srgbClr val="059669"/>
                 </a:solidFill>
@@ -3996,7 +4066,7 @@
       </p:sp>
       <p:sp>
         <p:nvSpPr>
-          <p:cNvPr id="16" name="Rectangle 15"/>
+          <p:cNvPr id="18" name="Rectangle 17"/>
           <p:cNvSpPr/>
           <p:nvPr/>
         </p:nvSpPr>
@@ -4039,7 +4109,7 @@
       </p:sp>
       <p:sp>
         <p:nvSpPr>
-          <p:cNvPr id="17" name="TextBox 16"/>
+          <p:cNvPr id="19" name="TextBox 18"/>
           <p:cNvSpPr txBox="1"/>
           <p:nvPr/>
         </p:nvSpPr>
@@ -4066,7 +4136,7 @@
                 </a:solidFill>
                 <a:latin typeface="Arial"/>
               </a:rPr>
-              <a:t>«Focus Media» — Toshkent Viloyati Maktablari Yagona Raqamli Media Tizimi</a:t>
+              <a:t>«Focus Media» — Toshkent Viloyati Umumta’lim Maktablari Yagona Raqamli Tizimi</a:t>
             </a:r>
             <a:r>
               <a:rPr sz="850">
@@ -4249,7 +4319,7 @@
                 </a:solidFill>
                 <a:latin typeface="Arial"/>
               </a:rPr>
-              <a:t>Viloyat maktablaridagi axborot bo‘shliqlarini zamonaviy raqamli mexanizmlar bilan bartaraf etish</a:t>
+              <a:t>Viloyat maktablaridagi axborot bo‘shliqlarini tezkor va tizimli bartaraf etish</a:t>
             </a:r>
           </a:p>
         </p:txBody>
@@ -4387,7 +4457,7 @@
                 </a:solidFill>
                 <a:latin typeface="Arial"/>
               </a:rPr>
-              <a:t>✖  Mavjud Holat (Muammo): </a:t>
+              <a:t>✖  Mavjud Muammo: </a:t>
             </a:r>
             <a:r>
               <a:rPr sz="950">
@@ -4396,7 +4466,7 @@
                 </a:solidFill>
                 <a:latin typeface="Arial"/>
               </a:rPr>
-              <a:t>22 ta tuman va shahardagi 900+ maktabdagi ta’lim jarayonlari, yutuqlar va muammolar markazga tarqoq, kechikib va tizimsiz yetib keladi. Yagona tahliliy baza mavjud emas.</a:t>
+              <a:t>900+ maktabdagi ta’lim holati, yutuqlar va muammolar markazga tarqoq, kechikib va tizimsiz yetib keladi. Yagona tahliliy monitoring bazasi yo‘q.</a:t>
             </a:r>
           </a:p>
           <a:p>
@@ -4559,7 +4629,7 @@
                 </a:solidFill>
                 <a:latin typeface="Arial"/>
               </a:rPr>
-              <a:t>✖  Mavjud Holat (Muammo): </a:t>
+              <a:t>✖  Mavjud Muammo: </a:t>
             </a:r>
             <a:r>
               <a:rPr sz="950">
@@ -4568,7 +4638,7 @@
                 </a:solidFill>
                 <a:latin typeface="Arial"/>
               </a:rPr>
-              <a:t>Ijtimoiy tarmoqlardagi feyk xabarlar, asossiz mish-mishlar va salbiy rezonanslarga rasmiy munosabat bildirish 24–48 soatgacha cho‘zilib ketadi.</a:t>
+              <a:t>Ijtimoiy tarmoqlardagi feyk xabarlar, asossiz mish-mishlar va salbiy rezonanslarga rasmiy munosabat bildirish 24–48 soatgacha kechikadi.</a:t>
             </a:r>
           </a:p>
           <a:p>
@@ -4593,7 +4663,7 @@
                 </a:solidFill>
                 <a:latin typeface="Arial"/>
               </a:rPr>
-              <a:t>«Kiber-Qalqon» dasturi va tasdiqlangan rasmiy media kanallar orqali 15 daqiqada tezkor rasmiy raddiya va tushuntirish berish mexanizmi joriy etiladi.</a:t>
+              <a:t>«Kiber-Qalqon» dasturi va rasmiy tasdiqlangan kanallar orqali 15 daqiqada tezkor rasmiy raddiya va tushuntirish berish mexanizmi joriy etiladi.</a:t>
             </a:r>
           </a:p>
         </p:txBody>
@@ -4731,7 +4801,7 @@
                 </a:solidFill>
                 <a:latin typeface="Arial"/>
               </a:rPr>
-              <a:t>✖  Mavjud Holat (Muammo): </a:t>
+              <a:t>✖  Mavjud Muammo: </a:t>
             </a:r>
             <a:r>
               <a:rPr sz="950">
@@ -4740,7 +4810,7 @@
                 </a:solidFill>
                 <a:latin typeface="Arial"/>
               </a:rPr>
-              <a:t>Olimpiada va sport chempionlari, innovatsion loyihalar yaratuvchi o‘quvchilar va ilg‘or pedagog ustozlar faqat o‘z maktabi doirasida tanilib, keng jamoatchilikka ko‘rinmaydi.</a:t>
+              <a:t>Olimpiada va sport chempionlari, innovatsion o‘quvchilar va ilg‘or pedagog ustozlar faqat o‘z maktabi doirasida tanilib, keng jamoatchilikka ko‘rinmaydi.</a:t>
             </a:r>
           </a:p>
           <a:p>
@@ -4842,7 +4912,7 @@
                 </a:solidFill>
                 <a:latin typeface="Arial"/>
               </a:rPr>
-              <a:t>«Focus Media» — Toshkent Viloyati Maktablari Yagona Raqamli Media Tizimi</a:t>
+              <a:t>«Focus Media» — Toshkent Viloyati Umumta’lim Maktablari Yagona Raqamli Tizimi</a:t>
             </a:r>
             <a:r>
               <a:rPr sz="850">
@@ -5025,7 +5095,7 @@
                 </a:solidFill>
                 <a:latin typeface="Arial"/>
               </a:rPr>
-              <a:t>Raqamli boshqaruv platformasi, milliy media-kontent portfeli va yoshlarni bepul kasbga yo‘naltirish</a:t>
+              <a:t>Raqamli boshqaruv platformasi, milliy media-kontent portfeli va zamonaviy kasblar</a:t>
             </a:r>
           </a:p>
         </p:txBody>
@@ -5038,8 +5108,8 @@
         </p:nvSpPr>
         <p:spPr>
           <a:xfrm>
-            <a:off x="731520" y="1463040"/>
-            <a:ext cx="3456432" cy="4617720"/>
+            <a:off x="7772400" y="1463040"/>
+            <a:ext cx="3687775" cy="4617720"/>
           </a:xfrm>
           <a:prstGeom prst="roundRect">
             <a:avLst/>
@@ -5075,49 +5145,30 @@
           </a:p>
         </p:txBody>
       </p:sp>
-      <p:sp>
-        <p:nvSpPr>
-          <p:cNvPr id="6" name="Rectangle 5"/>
-          <p:cNvSpPr/>
+      <p:pic>
+        <p:nvPicPr>
+          <p:cNvPr id="6" name="Picture 5" descr="illustration.jpg"/>
+          <p:cNvPicPr>
+            <a:picLocks noChangeAspect="1"/>
+          </p:cNvPicPr>
           <p:nvPr/>
-        </p:nvSpPr>
-        <p:spPr>
-          <a:xfrm>
-            <a:off x="731520" y="1463040"/>
-            <a:ext cx="3456432" cy="73152"/>
+        </p:nvPicPr>
+        <p:blipFill>
+          <a:blip r:embed="rId2"/>
+          <a:stretch>
+            <a:fillRect/>
+          </a:stretch>
+        </p:blipFill>
+        <p:spPr>
+          <a:xfrm>
+            <a:off x="7863840" y="1554480"/>
+            <a:ext cx="3504895" cy="1956816"/>
           </a:xfrm>
           <a:prstGeom prst="rect">
             <a:avLst/>
           </a:prstGeom>
-          <a:solidFill>
-            <a:srgbClr val="1E3A8A"/>
-          </a:solidFill>
-          <a:ln>
-            <a:noFill/>
-          </a:ln>
-        </p:spPr>
-        <p:style>
-          <a:lnRef idx="1">
-            <a:schemeClr val="accent1"/>
-          </a:lnRef>
-          <a:fillRef idx="3">
-            <a:schemeClr val="accent1"/>
-          </a:fillRef>
-          <a:effectRef idx="2">
-            <a:schemeClr val="accent1"/>
-          </a:effectRef>
-          <a:fontRef idx="minor">
-            <a:schemeClr val="lt1"/>
-          </a:fontRef>
-        </p:style>
-        <p:txBody>
-          <a:bodyPr rtlCol="0" anchor="ctr"/>
-          <a:lstStyle/>
-          <a:p>
-            <a:pPr algn="ctr"/>
-          </a:p>
-        </p:txBody>
-      </p:sp>
+        </p:spPr>
+      </p:pic>
       <p:sp>
         <p:nvSpPr>
           <p:cNvPr id="7" name="TextBox 6"/>
@@ -5126,8 +5177,8 @@
         </p:nvSpPr>
         <p:spPr>
           <a:xfrm>
-            <a:off x="914400" y="1645920"/>
-            <a:ext cx="3090672" cy="4297680"/>
+            <a:off x="7909560" y="3611880"/>
+            <a:ext cx="3413455" cy="2286000"/>
           </a:xfrm>
           <a:prstGeom prst="rect">
             <a:avLst/>
@@ -5141,91 +5192,46 @@
           <a:lstStyle/>
           <a:p>
             <a:r>
-              <a:rPr sz="1100" b="1">
+              <a:rPr sz="1000" b="1">
                 <a:solidFill>
                   <a:srgbClr val="1E3A8A"/>
                 </a:solidFill>
                 <a:latin typeface="Arial"/>
               </a:rPr>
-              <a:t>1-USTUN: RAQAMLI PLATFORMA &amp; KIBER-XAVFSIZLIK</a:t>
+              <a:t>ZAMONAVIY MEDIA STUDIYA</a:t>
             </a:r>
           </a:p>
           <a:p>
             <a:pPr>
               <a:spcBef>
-                <a:spcPts val="1400"/>
+                <a:spcPts val="400"/>
               </a:spcBef>
             </a:pPr>
             <a:r>
-              <a:rPr sz="1000" b="1">
-                <a:solidFill>
-                  <a:srgbClr val="0F172A"/>
-                </a:solidFill>
-                <a:latin typeface="Arial"/>
-              </a:rPr>
-              <a:t>●  Yagona Telegram Bot (@focusmedia4_bot):
-</a:t>
-            </a:r>
-            <a:r>
               <a:rPr sz="900">
                 <a:solidFill>
                   <a:srgbClr val="334155"/>
                 </a:solidFill>
                 <a:latin typeface="Arial"/>
               </a:rPr>
-              <a:t>24/7 rejimida viloyat yangiliklari, rasmiy dayjestlar, murojaatlar va 22 ta tuman reestri.</a:t>
+              <a:t>Har bir maktabning mavjud texnik imkoniyatlari (smartfon, mikrofon, noutbuk) negizida to‘liq avtomatlashtirilgan raqamli media infratuzilmasi shakllantiriladi.</a:t>
             </a:r>
           </a:p>
           <a:p>
             <a:pPr>
               <a:spcBef>
-                <a:spcPts val="1400"/>
+                <a:spcPts val="600"/>
               </a:spcBef>
             </a:pPr>
             <a:r>
-              <a:rPr sz="1000" b="1">
-                <a:solidFill>
-                  <a:srgbClr val="0F172A"/>
-                </a:solidFill>
-                <a:latin typeface="Arial"/>
-              </a:rPr>
-              <a:t>●  Veb-Monitoring Portali:
-</a:t>
-            </a:r>
-            <a:r>
-              <a:rPr sz="900">
-                <a:solidFill>
-                  <a:srgbClr val="334155"/>
-                </a:solidFill>
-                <a:latin typeface="Arial"/>
-              </a:rPr>
-              <a:t>Viloyat ta’lim boshqarmasi va hokimlik uchun ochiq, shaffof va tahliliy elektron platforma.</a:t>
-            </a:r>
-          </a:p>
-          <a:p>
-            <a:pPr>
-              <a:spcBef>
-                <a:spcPts val="1400"/>
-              </a:spcBef>
-            </a:pPr>
-            <a:r>
-              <a:rPr sz="1000" b="1">
-                <a:solidFill>
-                  <a:srgbClr val="0F172A"/>
-                </a:solidFill>
-                <a:latin typeface="Arial"/>
-              </a:rPr>
-              <a:t>●  «Kiber-Qalqon» Dasturi:
-</a:t>
-            </a:r>
-            <a:r>
-              <a:rPr sz="900">
-                <a:solidFill>
-                  <a:srgbClr val="334155"/>
-                </a:solidFill>
-                <a:latin typeface="Arial"/>
-              </a:rPr>
-              <a:t>O‘quvchilar va ota-onalar uchun kibergigiyena, shaxsiy ma’lumotlar himoyasi va kiberbullingdan saqlanish ko‘nikmalari.</a:t>
+              <a:rPr sz="850" b="1">
+                <a:solidFill>
+                  <a:srgbClr val="059669"/>
+                </a:solidFill>
+                <a:latin typeface="Arial"/>
+              </a:rPr>
+              <a:t>✔ Qo‘shimcha byudjet talab etilmaydi
+✔ 100% yoshlar amaliy ijodkorligi</a:t>
             </a:r>
           </a:p>
         </p:txBody>
@@ -5238,8 +5244,8 @@
         </p:nvSpPr>
         <p:spPr>
           <a:xfrm>
-            <a:off x="4370832" y="1463040"/>
-            <a:ext cx="3456432" cy="4617720"/>
+            <a:off x="731520" y="1463040"/>
+            <a:ext cx="6858000" cy="1444752"/>
           </a:xfrm>
           <a:prstGeom prst="roundRect">
             <a:avLst/>
@@ -5283,14 +5289,14 @@
         </p:nvSpPr>
         <p:spPr>
           <a:xfrm>
-            <a:off x="4370832" y="1463040"/>
-            <a:ext cx="3456432" cy="73152"/>
+            <a:off x="731520" y="1463040"/>
+            <a:ext cx="73152" cy="1444752"/>
           </a:xfrm>
           <a:prstGeom prst="rect">
             <a:avLst/>
           </a:prstGeom>
           <a:solidFill>
-            <a:srgbClr val="2563EB"/>
+            <a:srgbClr val="1E3A8A"/>
           </a:solidFill>
           <a:ln>
             <a:noFill/>
@@ -5326,8 +5332,8 @@
         </p:nvSpPr>
         <p:spPr>
           <a:xfrm>
-            <a:off x="4553712" y="1645920"/>
-            <a:ext cx="3090672" cy="4297680"/>
+            <a:off x="914400" y="1554480"/>
+            <a:ext cx="6583680" cy="1261872"/>
           </a:xfrm>
           <a:prstGeom prst="rect">
             <a:avLst/>
@@ -5341,91 +5347,88 @@
           <a:lstStyle/>
           <a:p>
             <a:r>
-              <a:rPr sz="1100" b="1">
-                <a:solidFill>
-                  <a:srgbClr val="2563EB"/>
-                </a:solidFill>
-                <a:latin typeface="Arial"/>
-              </a:rPr>
-              <a:t>2-USTUN: MILLIY MEDIA-KONTENT VA TARG‘IBOT</a:t>
+              <a:rPr sz="1050" b="1">
+                <a:solidFill>
+                  <a:srgbClr val="1E3A8A"/>
+                </a:solidFill>
+                <a:latin typeface="Arial"/>
+              </a:rPr>
+              <a:t>1-USTUN: RAQAMLI IT PLATFORMA &amp; KIBER-XAVFSIZLIK</a:t>
             </a:r>
           </a:p>
           <a:p>
             <a:pPr>
               <a:spcBef>
-                <a:spcPts val="1400"/>
+                <a:spcPts val="300"/>
               </a:spcBef>
             </a:pPr>
             <a:r>
-              <a:rPr sz="1000" b="1">
+              <a:rPr sz="880" b="1">
                 <a:solidFill>
                   <a:srgbClr val="0F172A"/>
                 </a:solidFill>
                 <a:latin typeface="Arial"/>
               </a:rPr>
-              <a:t>●  «Hafta Nigohi» Tahliliy Dayjesti:
-</a:t>
-            </a:r>
-            <a:r>
-              <a:rPr sz="900">
+              <a:t>● Yagona Telegram Bot (@focusmedia4_bot): </a:t>
+            </a:r>
+            <a:r>
+              <a:rPr sz="880">
                 <a:solidFill>
                   <a:srgbClr val="334155"/>
                 </a:solidFill>
                 <a:latin typeface="Arial"/>
               </a:rPr>
-              <a:t>Har hafta viloyat maktablaridagi namunali ochiq darslar, ilmiy yutuqlar va ta’limiy loyihalar sarasi.</a:t>
+              <a:t>24/7 rejimida viloyat yangiliklari, rasmiy dayjestlar va murojaat qabuli.</a:t>
             </a:r>
           </a:p>
           <a:p>
             <a:pPr>
               <a:spcBef>
-                <a:spcPts val="1400"/>
+                <a:spcPts val="300"/>
               </a:spcBef>
             </a:pPr>
             <a:r>
-              <a:rPr sz="1000" b="1">
+              <a:rPr sz="880" b="1">
                 <a:solidFill>
                   <a:srgbClr val="0F172A"/>
                 </a:solidFill>
                 <a:latin typeface="Arial"/>
               </a:rPr>
-              <a:t>●  «Focus Suhbat» Ma’rifiy Podkasti:
-</a:t>
-            </a:r>
-            <a:r>
-              <a:rPr sz="900">
+              <a:t>● Veb-Monitoring Portali: </a:t>
+            </a:r>
+            <a:r>
+              <a:rPr sz="880">
                 <a:solidFill>
                   <a:srgbClr val="334155"/>
                 </a:solidFill>
                 <a:latin typeface="Arial"/>
               </a:rPr>
-              <a:t>Ziyolilar, faxriy ustozlar, namunali yetakchi o‘quvchilar bilan blits-intervyular va mahorat darslari.</a:t>
+              <a:t>Viloyat ta’lim boshqarmasi uchun ochiq, shaffof va tahliliy elektron platforma.</a:t>
             </a:r>
           </a:p>
           <a:p>
             <a:pPr>
               <a:spcBef>
-                <a:spcPts val="1400"/>
+                <a:spcPts val="300"/>
               </a:spcBef>
             </a:pPr>
             <a:r>
-              <a:rPr sz="1000" b="1">
+              <a:rPr sz="880" b="1">
                 <a:solidFill>
                   <a:srgbClr val="0F172A"/>
                 </a:solidFill>
                 <a:latin typeface="Arial"/>
               </a:rPr>
-              <a:t>●  «Viloyat Iftixorlari» Reytingi:
-</a:t>
-            </a:r>
-            <a:r>
-              <a:rPr sz="900">
+              <a:t>● «Kiber-Qalqon» Dasturi: </a:t>
+            </a:r>
+            <a:r>
+              <a:rPr sz="880">
                 <a:solidFill>
                   <a:srgbClr val="334155"/>
                 </a:solidFill>
                 <a:latin typeface="Arial"/>
               </a:rPr>
-              <a:t>Xalqaro fan olimpiadalari, IT tanlovlari va sport chempionlari haqida maxsus ruknlar.</a:t>
+              <a:t>Kibergigiyena, shaxsiy ma’lumotlar himoyasi va kiberbulling profilaktikasi.</a:t>
             </a:r>
           </a:p>
         </p:txBody>
@@ -5438,8 +5441,8 @@
         </p:nvSpPr>
         <p:spPr>
           <a:xfrm>
-            <a:off x="8010144" y="1463040"/>
-            <a:ext cx="3456432" cy="4617720"/>
+            <a:off x="731520" y="3044952"/>
+            <a:ext cx="6858000" cy="1444752"/>
           </a:xfrm>
           <a:prstGeom prst="roundRect">
             <a:avLst/>
@@ -5483,8 +5486,205 @@
         </p:nvSpPr>
         <p:spPr>
           <a:xfrm>
-            <a:off x="8010144" y="1463040"/>
-            <a:ext cx="3456432" cy="73152"/>
+            <a:off x="731520" y="3044952"/>
+            <a:ext cx="73152" cy="1444752"/>
+          </a:xfrm>
+          <a:prstGeom prst="rect">
+            <a:avLst/>
+          </a:prstGeom>
+          <a:solidFill>
+            <a:srgbClr val="2563EB"/>
+          </a:solidFill>
+          <a:ln>
+            <a:noFill/>
+          </a:ln>
+        </p:spPr>
+        <p:style>
+          <a:lnRef idx="1">
+            <a:schemeClr val="accent1"/>
+          </a:lnRef>
+          <a:fillRef idx="3">
+            <a:schemeClr val="accent1"/>
+          </a:fillRef>
+          <a:effectRef idx="2">
+            <a:schemeClr val="accent1"/>
+          </a:effectRef>
+          <a:fontRef idx="minor">
+            <a:schemeClr val="lt1"/>
+          </a:fontRef>
+        </p:style>
+        <p:txBody>
+          <a:bodyPr rtlCol="0" anchor="ctr"/>
+          <a:lstStyle/>
+          <a:p>
+            <a:pPr algn="ctr"/>
+          </a:p>
+        </p:txBody>
+      </p:sp>
+      <p:sp>
+        <p:nvSpPr>
+          <p:cNvPr id="13" name="TextBox 12"/>
+          <p:cNvSpPr txBox="1"/>
+          <p:nvPr/>
+        </p:nvSpPr>
+        <p:spPr>
+          <a:xfrm>
+            <a:off x="914400" y="3136392"/>
+            <a:ext cx="6583680" cy="1261872"/>
+          </a:xfrm>
+          <a:prstGeom prst="rect">
+            <a:avLst/>
+          </a:prstGeom>
+          <a:noFill/>
+        </p:spPr>
+        <p:txBody>
+          <a:bodyPr wrap="square" lIns="0" tIns="0" rIns="0" bIns="0">
+            <a:spAutoFit/>
+          </a:bodyPr>
+          <a:lstStyle/>
+          <a:p>
+            <a:r>
+              <a:rPr sz="1050" b="1">
+                <a:solidFill>
+                  <a:srgbClr val="2563EB"/>
+                </a:solidFill>
+                <a:latin typeface="Arial"/>
+              </a:rPr>
+              <a:t>2-USTUN: MILLIY MEDIA-KONTENT VA TARG‘IBOT</a:t>
+            </a:r>
+          </a:p>
+          <a:p>
+            <a:pPr>
+              <a:spcBef>
+                <a:spcPts val="300"/>
+              </a:spcBef>
+            </a:pPr>
+            <a:r>
+              <a:rPr sz="880" b="1">
+                <a:solidFill>
+                  <a:srgbClr val="0F172A"/>
+                </a:solidFill>
+                <a:latin typeface="Arial"/>
+              </a:rPr>
+              <a:t>● «Hafta Nigohi» Dayjesti: </a:t>
+            </a:r>
+            <a:r>
+              <a:rPr sz="880">
+                <a:solidFill>
+                  <a:srgbClr val="334155"/>
+                </a:solidFill>
+                <a:latin typeface="Arial"/>
+              </a:rPr>
+              <a:t>Har hafta viloyat maktablaridagi namunali ochiq darslar va ilmiy yutuqlar sarasi.</a:t>
+            </a:r>
+          </a:p>
+          <a:p>
+            <a:pPr>
+              <a:spcBef>
+                <a:spcPts val="300"/>
+              </a:spcBef>
+            </a:pPr>
+            <a:r>
+              <a:rPr sz="880" b="1">
+                <a:solidFill>
+                  <a:srgbClr val="0F172A"/>
+                </a:solidFill>
+                <a:latin typeface="Arial"/>
+              </a:rPr>
+              <a:t>● «Focus Suhbat» Podkasti: </a:t>
+            </a:r>
+            <a:r>
+              <a:rPr sz="880">
+                <a:solidFill>
+                  <a:srgbClr val="334155"/>
+                </a:solidFill>
+                <a:latin typeface="Arial"/>
+              </a:rPr>
+              <a:t>Ziyolilar, faxriy ustozlar va iqtidorli yetakchi o‘quvchilar bilan intervyular.</a:t>
+            </a:r>
+          </a:p>
+          <a:p>
+            <a:pPr>
+              <a:spcBef>
+                <a:spcPts val="300"/>
+              </a:spcBef>
+            </a:pPr>
+            <a:r>
+              <a:rPr sz="880" b="1">
+                <a:solidFill>
+                  <a:srgbClr val="0F172A"/>
+                </a:solidFill>
+                <a:latin typeface="Arial"/>
+              </a:rPr>
+              <a:t>● «Viloyat Iftixorlari» Reytingi: </a:t>
+            </a:r>
+            <a:r>
+              <a:rPr sz="880">
+                <a:solidFill>
+                  <a:srgbClr val="334155"/>
+                </a:solidFill>
+                <a:latin typeface="Arial"/>
+              </a:rPr>
+              <a:t>Xalqaro fan olimpiadalari va sport chempionlarini keng ommalashtirish.</a:t>
+            </a:r>
+          </a:p>
+        </p:txBody>
+      </p:sp>
+      <p:sp>
+        <p:nvSpPr>
+          <p:cNvPr id="14" name="Rounded Rectangle 13"/>
+          <p:cNvSpPr/>
+          <p:nvPr/>
+        </p:nvSpPr>
+        <p:spPr>
+          <a:xfrm>
+            <a:off x="731520" y="4626864"/>
+            <a:ext cx="6858000" cy="1444752"/>
+          </a:xfrm>
+          <a:prstGeom prst="roundRect">
+            <a:avLst/>
+          </a:prstGeom>
+          <a:solidFill>
+            <a:srgbClr val="F8FAFC"/>
+          </a:solidFill>
+          <a:ln w="12700">
+            <a:solidFill>
+              <a:srgbClr val="E2E8F0"/>
+            </a:solidFill>
+          </a:ln>
+        </p:spPr>
+        <p:style>
+          <a:lnRef idx="1">
+            <a:schemeClr val="accent1"/>
+          </a:lnRef>
+          <a:fillRef idx="3">
+            <a:schemeClr val="accent1"/>
+          </a:fillRef>
+          <a:effectRef idx="2">
+            <a:schemeClr val="accent1"/>
+          </a:effectRef>
+          <a:fontRef idx="minor">
+            <a:schemeClr val="lt1"/>
+          </a:fontRef>
+        </p:style>
+        <p:txBody>
+          <a:bodyPr rtlCol="0" anchor="ctr"/>
+          <a:lstStyle/>
+          <a:p>
+            <a:pPr algn="ctr"/>
+          </a:p>
+        </p:txBody>
+      </p:sp>
+      <p:sp>
+        <p:nvSpPr>
+          <p:cNvPr id="15" name="Rectangle 14"/>
+          <p:cNvSpPr/>
+          <p:nvPr/>
+        </p:nvSpPr>
+        <p:spPr>
+          <a:xfrm>
+            <a:off x="731520" y="4626864"/>
+            <a:ext cx="73152" cy="1444752"/>
           </a:xfrm>
           <a:prstGeom prst="rect">
             <a:avLst/>
@@ -5520,14 +5720,14 @@
       </p:sp>
       <p:sp>
         <p:nvSpPr>
-          <p:cNvPr id="13" name="TextBox 12"/>
+          <p:cNvPr id="16" name="TextBox 15"/>
           <p:cNvSpPr txBox="1"/>
           <p:nvPr/>
         </p:nvSpPr>
         <p:spPr>
           <a:xfrm>
-            <a:off x="8193024" y="1645920"/>
-            <a:ext cx="3090672" cy="4297680"/>
+            <a:off x="914400" y="4718304"/>
+            <a:ext cx="6583680" cy="1261872"/>
           </a:xfrm>
           <a:prstGeom prst="rect">
             <a:avLst/>
@@ -5541,7 +5741,7 @@
           <a:lstStyle/>
           <a:p>
             <a:r>
-              <a:rPr sz="1100" b="1">
+              <a:rPr sz="1050" b="1">
                 <a:solidFill>
                   <a:srgbClr val="0E7490"/>
                 </a:solidFill>
@@ -5553,86 +5753,83 @@
           <a:p>
             <a:pPr>
               <a:spcBef>
-                <a:spcPts val="1400"/>
+                <a:spcPts val="300"/>
               </a:spcBef>
             </a:pPr>
             <a:r>
-              <a:rPr sz="1000" b="1">
+              <a:rPr sz="880" b="1">
                 <a:solidFill>
                   <a:srgbClr val="0F172A"/>
                 </a:solidFill>
                 <a:latin typeface="Arial"/>
               </a:rPr>
-              <a:t>●  Low-Cost Mobil Studiya Modeli:
-</a:t>
-            </a:r>
-            <a:r>
-              <a:rPr sz="900">
+              <a:t>● Low-Cost Mobil Studiya Modeli: </a:t>
+            </a:r>
+            <a:r>
+              <a:rPr sz="880">
                 <a:solidFill>
                   <a:srgbClr val="334155"/>
                 </a:solidFill>
                 <a:latin typeface="Arial"/>
               </a:rPr>
-              <a:t>Qo‘shimcha qimmat xaridlarsiz, har bir maktabning mavjud smartfon va kompyuterlari negizida media-burchak.</a:t>
+              <a:t>Mavjud smartfon va kompyuterlar negizida maktab media-burchagi.</a:t>
             </a:r>
           </a:p>
           <a:p>
             <a:pPr>
               <a:spcBef>
-                <a:spcPts val="1400"/>
+                <a:spcPts val="300"/>
               </a:spcBef>
             </a:pPr>
             <a:r>
-              <a:rPr sz="1000" b="1">
+              <a:rPr sz="880" b="1">
                 <a:solidFill>
                   <a:srgbClr val="0F172A"/>
                 </a:solidFill>
                 <a:latin typeface="Arial"/>
               </a:rPr>
-              <a:t>●  5,000+ Yoshlarni Kasbga Yo‘naltirish:
-</a:t>
-            </a:r>
-            <a:r>
-              <a:rPr sz="900">
+              <a:t>● 5,000+ Yoshlarni Kasbga Yo‘naltirish: </a:t>
+            </a:r>
+            <a:r>
+              <a:rPr sz="880">
                 <a:solidFill>
                   <a:srgbClr val="334155"/>
                 </a:solidFill>
                 <a:latin typeface="Arial"/>
               </a:rPr>
-              <a:t>SMM, mobilografiya, montaj, kompyuter grafikasi va jurnalistika sohalariga bepul amaliy yo‘naltirish.</a:t>
+              <a:t>SMM, mobilografiya, montaj va jurnalistika sohalariga bepul o‘qitish.</a:t>
             </a:r>
           </a:p>
           <a:p>
             <a:pPr>
               <a:spcBef>
-                <a:spcPts val="1400"/>
+                <a:spcPts val="300"/>
               </a:spcBef>
             </a:pPr>
             <a:r>
-              <a:rPr sz="1000" b="1">
+              <a:rPr sz="880" b="1">
                 <a:solidFill>
                   <a:srgbClr val="0F172A"/>
                 </a:solidFill>
                 <a:latin typeface="Arial"/>
               </a:rPr>
-              <a:t>●  Maktab Ma’muriyatiga Yordamchi:
-</a:t>
-            </a:r>
-            <a:r>
-              <a:rPr sz="900">
+              <a:t>● Maktab Ma’muriyatiga Yordamchi: </a:t>
+            </a:r>
+            <a:r>
+              <a:rPr sz="880">
                 <a:solidFill>
                   <a:srgbClr val="334155"/>
                 </a:solidFill>
                 <a:latin typeface="Arial"/>
               </a:rPr>
-              <a:t>Maktabning ijobiy imijini yuksaltiruvchi va rasmiy tadbirlarni yorituvchi tayyor o‘quvchilar jamoasi.</a:t>
-            </a:r>
-          </a:p>
-        </p:txBody>
-      </p:sp>
-      <p:sp>
-        <p:nvSpPr>
-          <p:cNvPr id="14" name="Rectangle 13"/>
+              <a:t>Maktabning ijobiy imijini yuksaltiruvchi tayyor o‘quvchilar jamoasi.</a:t>
+            </a:r>
+          </a:p>
+        </p:txBody>
+      </p:sp>
+      <p:sp>
+        <p:nvSpPr>
+          <p:cNvPr id="17" name="Rectangle 16"/>
           <p:cNvSpPr/>
           <p:nvPr/>
         </p:nvSpPr>
@@ -5675,7 +5872,7 @@
       </p:sp>
       <p:sp>
         <p:nvSpPr>
-          <p:cNvPr id="15" name="TextBox 14"/>
+          <p:cNvPr id="18" name="TextBox 17"/>
           <p:cNvSpPr txBox="1"/>
           <p:nvPr/>
         </p:nvSpPr>
@@ -5702,7 +5899,7 @@
                 </a:solidFill>
                 <a:latin typeface="Arial"/>
               </a:rPr>
-              <a:t>«Focus Media» — Toshkent Viloyati Maktablari Yagona Raqamli Media Tizimi</a:t>
+              <a:t>«Focus Media» — Toshkent Viloyati Umumta’lim Maktablari Yagona Raqamli Tizimi</a:t>
             </a:r>
             <a:r>
               <a:rPr sz="850">
@@ -5835,7 +6032,7 @@
                 </a:solidFill>
                 <a:latin typeface="Arial"/>
               </a:rPr>
-              <a:t>TASHKILIY TUZILMA VA AMALGA OSHIRISH MEXANIZMI</a:t>
+              <a:t>TASHKILIY TUZILMA VA IJRO MEXANIZMI</a:t>
             </a:r>
           </a:p>
         </p:txBody>
@@ -5885,7 +6082,7 @@
                 </a:solidFill>
                 <a:latin typeface="Arial"/>
               </a:rPr>
-              <a:t>Qo‘shimcha shtat talab etmaydigan boshqaruv tizimi va viloyat bo‘yicha aniq joriy etish bosqichlari</a:t>
+              <a:t>Qo‘shimcha shtat talab etmaydigan boshqaruv va viloyat bo‘yicha aniq joriy etish bosqichlari</a:t>
             </a:r>
           </a:p>
         </p:txBody>
@@ -6013,7 +6210,7 @@
           <a:p>
             <a:pPr>
               <a:spcBef>
-                <a:spcPts val="1100"/>
+                <a:spcPts val="1200"/>
               </a:spcBef>
             </a:pPr>
             <a:r>
@@ -6033,13 +6230,13 @@
                 </a:solidFill>
                 <a:latin typeface="Arial"/>
               </a:rPr>
-              <a:t>Yoshlar yetakchisi yoki Informatika fani o‘qituvchisi. Strategik rejalashtirish, maktab ma’muriyati va tuman ta’lim bo‘limi bilan aloqa hamda IT nazorati.</a:t>
+              <a:t>Yoshlar yetakchisi / Informatika fani o‘qituvchisi. Strategik reja, tuman ta’lim bo‘limi bilan aloqa va IT nazorati.</a:t>
             </a:r>
           </a:p>
           <a:p>
             <a:pPr>
               <a:spcBef>
-                <a:spcPts val="1100"/>
+                <a:spcPts val="1200"/>
               </a:spcBef>
             </a:pPr>
             <a:r>
@@ -6065,7 +6262,7 @@
           <a:p>
             <a:pPr>
               <a:spcBef>
-                <a:spcPts val="1100"/>
+                <a:spcPts val="1200"/>
               </a:spcBef>
             </a:pPr>
             <a:r>
@@ -6085,13 +6282,13 @@
                 </a:solidFill>
                 <a:latin typeface="Arial"/>
               </a:rPr>
-              <a:t>1-2 nafar kompyuter grafikasi havaskori. Yagona brending asosida rasmiy e’lonlar, posterlar va infografik materiallarni tayyorlash.</a:t>
+              <a:t>1-2 nafar havaskor o‘quvchi. Yagona brending asosida rasmiy e’lonlar, posterlar va infografik materiallar tayyorlash.</a:t>
             </a:r>
           </a:p>
           <a:p>
             <a:pPr>
               <a:spcBef>
-                <a:spcPts val="1100"/>
+                <a:spcPts val="1200"/>
               </a:spcBef>
             </a:pPr>
             <a:r>
@@ -6111,7 +6308,7 @@
                 </a:solidFill>
                 <a:latin typeface="Arial"/>
               </a:rPr>
-              <a:t>2-3 nafar ijodkor o‘quvchi. Tahliliy maqolalar, ustoz va tengdoshlar bilan intervyular hamda rasmiy xabarlarni tayyorlash.</a:t>
+              <a:t>2-3 nafar ijodkor o‘quvchi. Tahliliy maqolalar, ustoz va tengdoshlar bilan intervyular hamda rasmiy xabarlar tayyorlash.</a:t>
             </a:r>
           </a:p>
         </p:txBody>
@@ -6239,7 +6436,7 @@
           <a:p>
             <a:pPr>
               <a:spcBef>
-                <a:spcPts val="1100"/>
+                <a:spcPts val="1200"/>
               </a:spcBef>
             </a:pPr>
             <a:r>
@@ -6259,13 +6456,13 @@
                 </a:solidFill>
                 <a:latin typeface="Arial"/>
               </a:rPr>
-              <a:t>Maktabgacha va maktab ta’limi boshqarmasining tegishli buyrug‘ini chiqarish, 22 ta tuman va shaharda 1 tadan (jami 22 ta) tayanch pilot maktablarini belgilash hamda mas’ullarni tayinlash.</a:t>
+              <a:t>Boshqarma buyrug‘ini qabul qilish va 22 ta tuman/shaharda 1 tadan (jami 22 ta) tayanch pilot maktablarini belgilash hamda mas’ullarni tayinlash.</a:t>
             </a:r>
           </a:p>
           <a:p>
             <a:pPr>
               <a:spcBef>
-                <a:spcPts val="1100"/>
+                <a:spcPts val="1200"/>
               </a:spcBef>
             </a:pPr>
             <a:r>
@@ -6285,13 +6482,13 @@
                 </a:solidFill>
                 <a:latin typeface="Arial"/>
               </a:rPr>
-              <a:t>22 ta tayanch maktab media guruhlari uchun 3 kunlik intensiv master-klasslar o‘tkazish, yagona «Focus Media Brandbook» hamda mobil studiya standartlarini tarqatish.</a:t>
+              <a:t>22 ta tayanch maktab media guruhlari uchun 3 kunlik intensiv master-klasslar o‘tkazish, yagona «Focus Media Brandbook» standartlarini tarqatish.</a:t>
             </a:r>
           </a:p>
           <a:p>
             <a:pPr>
               <a:spcBef>
-                <a:spcPts val="1100"/>
+                <a:spcPts val="1200"/>
               </a:spcBef>
             </a:pPr>
             <a:r>
@@ -6311,13 +6508,13 @@
                 </a:solidFill>
                 <a:latin typeface="Arial"/>
               </a:rPr>
-              <a:t>«Focus Bot» va viloyat elektron platformasini to‘liq ishga tushirish, haftalik «Hafta Nigohi» tahliliy dayjestlarini muntazam efirga uzatish va «Kiber-Qalqon» tizimini darslarga bog‘lash.</a:t>
+              <a:t>«Focus Bot» va elektron platformani ishga tushirish, haftalik «Hafta Nigohi» tahliliy dayjestlarini efirga berish hamda «Kiber-Qalqon» tizimini darslarga bog‘lash.</a:t>
             </a:r>
           </a:p>
           <a:p>
             <a:pPr>
               <a:spcBef>
-                <a:spcPts val="1100"/>
+                <a:spcPts val="1200"/>
               </a:spcBef>
             </a:pPr>
             <a:r>
@@ -6337,7 +6534,7 @@
                 </a:solidFill>
                 <a:latin typeface="Arial"/>
               </a:rPr>
-              <a:t>Tizimni viloyatdagi qolgan 900+ maktabga bosqichma-bosqich tatbiq etish, har oy yakuni bo‘yicha «Eng Faol Maktab Media Markazi» reytingini e’lon qilish va yillik «Viloyat Media Forumi»ni o‘tkazish.</a:t>
+              <a:t>Tizimni viloyatdagi 900+ maktabga tatbiq etish, har oy yakuni bo‘yicha «Eng Faol Maktab Media Markazi» reytingini e’lon qilish va yillik Forum o‘tkazish.</a:t>
             </a:r>
           </a:p>
         </p:txBody>
@@ -6414,7 +6611,7 @@
                 </a:solidFill>
                 <a:latin typeface="Arial"/>
               </a:rPr>
-              <a:t>«Focus Media» — Toshkent Viloyati Maktablari Yagona Raqamli Media Tizimi</a:t>
+              <a:t>«Focus Media» — Toshkent Viloyati Umumta’lim Maktablari Yagona Raqamli Tizimi</a:t>
             </a:r>
             <a:r>
               <a:rPr sz="850">
@@ -6602,9 +6799,33 @@
           </a:p>
         </p:txBody>
       </p:sp>
-      <p:sp>
-        <p:nvSpPr>
-          <p:cNvPr id="5" name="Rounded Rectangle 4"/>
+      <p:pic>
+        <p:nvPicPr>
+          <p:cNvPr id="5" name="Picture 4" descr="logo.jpg"/>
+          <p:cNvPicPr>
+            <a:picLocks noChangeAspect="1"/>
+          </p:cNvPicPr>
+          <p:nvPr/>
+        </p:nvPicPr>
+        <p:blipFill>
+          <a:blip r:embed="rId2"/>
+          <a:stretch>
+            <a:fillRect/>
+          </a:stretch>
+        </p:blipFill>
+        <p:spPr>
+          <a:xfrm>
+            <a:off x="10424160" y="438912"/>
+            <a:ext cx="1005840" cy="1005840"/>
+          </a:xfrm>
+          <a:prstGeom prst="rect">
+            <a:avLst/>
+          </a:prstGeom>
+        </p:spPr>
+      </p:pic>
+      <p:sp>
+        <p:nvSpPr>
+          <p:cNvPr id="6" name="Rounded Rectangle 5"/>
           <p:cNvSpPr/>
           <p:nvPr/>
         </p:nvSpPr>
@@ -6690,7 +6911,7 @@
       </p:sp>
       <p:sp>
         <p:nvSpPr>
-          <p:cNvPr id="6" name="Rectangle 5"/>
+          <p:cNvPr id="7" name="Rectangle 6"/>
           <p:cNvSpPr/>
           <p:nvPr/>
         </p:nvSpPr>
@@ -6733,7 +6954,7 @@
       </p:sp>
       <p:sp>
         <p:nvSpPr>
-          <p:cNvPr id="7" name="Rounded Rectangle 6"/>
+          <p:cNvPr id="8" name="Rounded Rectangle 7"/>
           <p:cNvSpPr/>
           <p:nvPr/>
         </p:nvSpPr>
@@ -6819,7 +7040,7 @@
       </p:sp>
       <p:sp>
         <p:nvSpPr>
-          <p:cNvPr id="8" name="Rectangle 7"/>
+          <p:cNvPr id="9" name="Rectangle 8"/>
           <p:cNvSpPr/>
           <p:nvPr/>
         </p:nvSpPr>
@@ -6862,7 +7083,7 @@
       </p:sp>
       <p:sp>
         <p:nvSpPr>
-          <p:cNvPr id="9" name="Rounded Rectangle 8"/>
+          <p:cNvPr id="10" name="Rounded Rectangle 9"/>
           <p:cNvSpPr/>
           <p:nvPr/>
         </p:nvSpPr>
@@ -6948,7 +7169,7 @@
       </p:sp>
       <p:sp>
         <p:nvSpPr>
-          <p:cNvPr id="10" name="Rectangle 9"/>
+          <p:cNvPr id="11" name="Rectangle 10"/>
           <p:cNvSpPr/>
           <p:nvPr/>
         </p:nvSpPr>
@@ -6991,7 +7212,7 @@
       </p:sp>
       <p:sp>
         <p:nvSpPr>
-          <p:cNvPr id="11" name="Rounded Rectangle 10"/>
+          <p:cNvPr id="12" name="Rounded Rectangle 11"/>
           <p:cNvSpPr/>
           <p:nvPr/>
         </p:nvSpPr>
@@ -7077,7 +7298,7 @@
       </p:sp>
       <p:sp>
         <p:nvSpPr>
-          <p:cNvPr id="12" name="Rectangle 11"/>
+          <p:cNvPr id="13" name="Rectangle 12"/>
           <p:cNvSpPr/>
           <p:nvPr/>
         </p:nvSpPr>
@@ -7120,7 +7341,7 @@
       </p:sp>
       <p:sp>
         <p:nvSpPr>
-          <p:cNvPr id="13" name="Rounded Rectangle 12"/>
+          <p:cNvPr id="14" name="Rounded Rectangle 13"/>
           <p:cNvSpPr/>
           <p:nvPr/>
         </p:nvSpPr>
@@ -7190,7 +7411,7 @@
       </p:sp>
       <p:sp>
         <p:nvSpPr>
-          <p:cNvPr id="14" name="Rectangle 13"/>
+          <p:cNvPr id="15" name="Rectangle 14"/>
           <p:cNvSpPr/>
           <p:nvPr/>
         </p:nvSpPr>
@@ -7233,7 +7454,7 @@
       </p:sp>
       <p:sp>
         <p:nvSpPr>
-          <p:cNvPr id="15" name="Rounded Rectangle 14"/>
+          <p:cNvPr id="16" name="Rounded Rectangle 15"/>
           <p:cNvSpPr/>
           <p:nvPr/>
         </p:nvSpPr>
@@ -7303,7 +7524,7 @@
       </p:sp>
       <p:sp>
         <p:nvSpPr>
-          <p:cNvPr id="16" name="Rectangle 15"/>
+          <p:cNvPr id="17" name="Rectangle 16"/>
           <p:cNvSpPr/>
           <p:nvPr/>
         </p:nvSpPr>
@@ -7346,7 +7567,7 @@
       </p:sp>
       <p:sp>
         <p:nvSpPr>
-          <p:cNvPr id="17" name="Rounded Rectangle 16"/>
+          <p:cNvPr id="18" name="Rounded Rectangle 17"/>
           <p:cNvSpPr/>
           <p:nvPr/>
         </p:nvSpPr>
@@ -7416,7 +7637,7 @@
       </p:sp>
       <p:sp>
         <p:nvSpPr>
-          <p:cNvPr id="18" name="Rectangle 17"/>
+          <p:cNvPr id="19" name="Rectangle 18"/>
           <p:cNvSpPr/>
           <p:nvPr/>
         </p:nvSpPr>
@@ -7459,7 +7680,7 @@
       </p:sp>
       <p:sp>
         <p:nvSpPr>
-          <p:cNvPr id="19" name="Rounded Rectangle 18"/>
+          <p:cNvPr id="20" name="Rounded Rectangle 19"/>
           <p:cNvSpPr/>
           <p:nvPr/>
         </p:nvSpPr>
@@ -7529,7 +7750,7 @@
       </p:sp>
       <p:sp>
         <p:nvSpPr>
-          <p:cNvPr id="20" name="Rectangle 19"/>
+          <p:cNvPr id="21" name="Rectangle 20"/>
           <p:cNvSpPr/>
           <p:nvPr/>
         </p:nvSpPr>
@@ -7572,7 +7793,7 @@
       </p:sp>
       <p:sp>
         <p:nvSpPr>
-          <p:cNvPr id="21" name="TextBox 20"/>
+          <p:cNvPr id="22" name="TextBox 21"/>
           <p:cNvSpPr txBox="1"/>
           <p:nvPr/>
         </p:nvSpPr>
@@ -7599,7 +7820,7 @@
                 </a:solidFill>
                 <a:latin typeface="Arial"/>
               </a:rPr>
-              <a:t>«Focus Media» — Toshkent Viloyati Maktablari Yagona Raqamli Media Tizimi</a:t>
+              <a:t>«Focus Media» — Toshkent Viloyati Umumta’lim Maktablari Yagona Raqamli Tizimi</a:t>
             </a:r>
             <a:r>
               <a:rPr sz="850">

</xml_diff>

<commit_message>
Update: 5-slide pure Uzbek executive presentation deck (.pptx)
</commit_message>
<xml_diff>
--- a/Focus_Media_Toshkent_Viloyati_5_Slayd.pptx
+++ b/Focus_Media_Toshkent_Viloyati_5_Slayd.pptx
@@ -3144,7 +3144,7 @@
         <p:spPr>
           <a:xfrm>
             <a:off x="731520" y="548640"/>
-            <a:ext cx="2560320" cy="292608"/>
+            <a:ext cx="2286000" cy="292608"/>
           </a:xfrm>
           <a:prstGeom prst="roundRect">
             <a:avLst/>
@@ -3228,7 +3228,7 @@
                 <a:latin typeface="Arial"/>
               </a:rPr>
               <a:t>
-Toshkent viloyati umumta’lim muassasalarining yagona raqamli tizimi</a:t>
+Toshkent viloyati umumta’lim maktablarining yagona raqamli tizimi</a:t>
             </a:r>
           </a:p>
           <a:p>
@@ -3244,7 +3244,7 @@
                 </a:solidFill>
                 <a:latin typeface="Arial"/>
               </a:rPr>
-              <a:t>Axborot boshqaruvi, tezkor ochiqlik va yoshlar intellektual salohiyatini yagona tizimga birlashtiruvchi loyiha.</a:t>
+              <a:t>Viloyat maktablarida axborot boshqaruvi, ochiqlik va yoshlar iqtidorini yagona tizimga birlashtirish.</a:t>
             </a:r>
           </a:p>
         </p:txBody>
@@ -3367,7 +3367,7 @@
                 </a:solidFill>
                 <a:latin typeface="Arial"/>
               </a:rPr>
-              <a:t>LOYIHA BOSH G‘OYASI:</a:t>
+              <a:t>BOSH G‘OYA:</a:t>
             </a:r>
           </a:p>
           <a:p>
@@ -3383,7 +3383,7 @@
                 </a:solidFill>
                 <a:latin typeface="Arial"/>
               </a:rPr>
-              <a:t>«Focus Media — bu shunchaki axborot kanali emas, balki Toshkent viloyati yoshlarining intellektual salohiyati, vatanparvarligi va zamonaviy imijini namoyon etuvchi raqamli ko‘zgudir!»</a:t>
+              <a:t>«Toshkent viloyati maktablarining ta’lim sifati, o‘quvchilar yutuqlari va ochiqligini ta’minlovchi yagona milliy axborot maydoni.»</a:t>
             </a:r>
           </a:p>
         </p:txBody>
@@ -3496,7 +3496,7 @@
                 </a:solidFill>
                 <a:latin typeface="Arial"/>
               </a:rPr>
-              <a:t>22 Ta Hudud</a:t>
+              <a:t>22 Ta Tuman / Shahar</a:t>
             </a:r>
           </a:p>
           <a:p>
@@ -3512,7 +3512,7 @@
                 </a:solidFill>
                 <a:latin typeface="Arial"/>
               </a:rPr>
-              <a:t>Toshkent viloyatining barcha tuman va shaharlari (900+ maktab)</a:t>
+              <a:t>Viloyatning barcha 900+ maktabi yagona axborot tizimiga ulanadi</a:t>
             </a:r>
           </a:p>
         </p:txBody>
@@ -3641,7 +3641,7 @@
                 </a:solidFill>
                 <a:latin typeface="Arial"/>
               </a:rPr>
-              <a:t>Viloyat o‘quvchilari, ota-onalar va 50,000+ pedagog jamoasi</a:t>
+              <a:t>Viloyat o‘quvchilari, ota-onalar va 50,000+ pedagoglar jamoasi</a:t>
             </a:r>
           </a:p>
         </p:txBody>
@@ -3754,7 +3754,7 @@
                 </a:solidFill>
                 <a:latin typeface="Arial"/>
               </a:rPr>
-              <a:t>Kam Xarajatli (Low-Cost)</a:t>
+              <a:t>0 So‘m (Tejamkor)</a:t>
             </a:r>
           </a:p>
           <a:p>
@@ -3770,7 +3770,7 @@
                 </a:solidFill>
                 <a:latin typeface="Arial"/>
               </a:rPr>
-              <a:t>Qo‘shimcha shtat talab etmaydi; maktablarning mavjud bazasi asosida</a:t>
+              <a:t>Qo‘shimcha shtat talab etmaydi; maktablarning mavjud texnikasi asosida</a:t>
             </a:r>
           </a:p>
         </p:txBody>
@@ -3867,7 +3867,7 @@
                 </a:solidFill>
                 <a:latin typeface="Arial"/>
               </a:rPr>
-              <a:t>JORIY ETISH</a:t>
+              <a:t>BOSQICHLAR</a:t>
             </a:r>
           </a:p>
           <a:p>
@@ -3899,7 +3899,7 @@
                 </a:solidFill>
                 <a:latin typeface="Arial"/>
               </a:rPr>
-              <a:t>1 oyda 22 ta pilot tayanch maktabi, 4 oyda viloyat to‘liq qamrovi</a:t>
+              <a:t>1 oyda 22 ta tayanch maktab, 4 oyda viloyat bo‘yicha to‘liq qamrov</a:t>
             </a:r>
           </a:p>
         </p:txBody>
@@ -3990,76 +3990,13 @@
           <a:p>
             <a:pPr algn="ctr"/>
             <a:r>
-              <a:rPr sz="950">
-                <a:solidFill>
-                  <a:srgbClr val="64748B"/>
-                </a:solidFill>
-                <a:latin typeface="Arial"/>
-              </a:rPr>
-              <a:t>Loyiha Tashabbuskori: </a:t>
-            </a:r>
-            <a:r>
               <a:rPr sz="950" b="1">
                 <a:solidFill>
-                  <a:srgbClr val="0F172A"/>
-                </a:solidFill>
-                <a:latin typeface="Arial"/>
-              </a:rPr>
-              <a:t>To‘rabek Abduvoitov</a:t>
-            </a:r>
-            <a:r>
-              <a:rPr sz="950">
-                <a:solidFill>
-                  <a:srgbClr val="64748B"/>
-                </a:solidFill>
-                <a:latin typeface="Arial"/>
-              </a:rPr>
-              <a:t>   |   Telegram: </a:t>
-            </a:r>
-            <a:r>
-              <a:rPr sz="950" b="1">
-                <a:solidFill>
-                  <a:srgbClr val="2563EB"/>
-                </a:solidFill>
-                <a:latin typeface="Arial"/>
-              </a:rPr>
-              <a:t>@Torabek_Abduvoitov</a:t>
-            </a:r>
-            <a:r>
-              <a:rPr sz="950">
-                <a:solidFill>
-                  <a:srgbClr val="64748B"/>
-                </a:solidFill>
-                <a:latin typeface="Arial"/>
-              </a:rPr>
-              <a:t>   |   Bot: </a:t>
-            </a:r>
-            <a:r>
-              <a:rPr sz="950" b="1">
-                <a:solidFill>
                   <a:srgbClr val="1E3A8A"/>
                 </a:solidFill>
                 <a:latin typeface="Arial"/>
               </a:rPr>
-              <a:t>@focusmedia4_bot</a:t>
-            </a:r>
-            <a:r>
-              <a:rPr sz="950">
-                <a:solidFill>
-                  <a:srgbClr val="64748B"/>
-                </a:solidFill>
-                <a:latin typeface="Arial"/>
-              </a:rPr>
-              <a:t>   |   Portal: </a:t>
-            </a:r>
-            <a:r>
-              <a:rPr sz="950" b="1">
-                <a:solidFill>
-                  <a:srgbClr val="059669"/>
-                </a:solidFill>
-                <a:latin typeface="Arial"/>
-              </a:rPr>
-              <a:t>focus-media-toshkent.vercel.app</a:t>
+              <a:t>Loyiha Tashabbuskori: To‘rabek Abduvoitov   |   Telegram: @Torabek_Abduvoitov   |   Bot: @focusmedia4_bot   |   Sahifa: focus-media-toshkent.vercel.app</a:t>
             </a:r>
           </a:p>
         </p:txBody>
@@ -4136,7 +4073,7 @@
                 </a:solidFill>
                 <a:latin typeface="Arial"/>
               </a:rPr>
-              <a:t>«Focus Media» — Toshkent Viloyati Umumta’lim Maktablari Yagona Raqamli Tizimi</a:t>
+              <a:t>«Focus Media» — Toshkent Viloyati Maktablarining Yagona Raqamli Axborot Tizimi</a:t>
             </a:r>
             <a:r>
               <a:rPr sz="850">
@@ -4145,7 +4082,7 @@
                 </a:solidFill>
                 <a:latin typeface="Arial"/>
               </a:rPr>
-              <a:t>   |   Rasmiy aloqa: @Torabek_Abduvoitov   |   Bot: @focusmedia4_bot</a:t>
+              <a:t>   |   Loyiha tashabbuskori: To‘rabek Abduvoitov (@Torabek_Abduvoitov)   |   Bot: @focusmedia4_bot</a:t>
             </a:r>
             <a:r>
               <a:rPr sz="850" b="1">
@@ -4154,7 +4091,7 @@
                 </a:solidFill>
                 <a:latin typeface="Arial"/>
               </a:rPr>
-              <a:t>   |   Slayd 1 / 5</a:t>
+              <a:t>   |   1 / 5-sahifa</a:t>
             </a:r>
           </a:p>
         </p:txBody>
@@ -4269,7 +4206,7 @@
                 </a:solidFill>
                 <a:latin typeface="Arial"/>
               </a:rPr>
-              <a:t>STRATEGIK TAHLIL VA DOLZARBLIK</a:t>
+              <a:t>TAHLIL VA DOLZARBLIK</a:t>
             </a:r>
           </a:p>
         </p:txBody>
@@ -4283,7 +4220,7 @@
         <p:spPr>
           <a:xfrm>
             <a:off x="731520" y="804672"/>
-            <a:ext cx="10728655" cy="457200"/>
+            <a:ext cx="10728655" cy="502920"/>
           </a:xfrm>
           <a:prstGeom prst="rect">
             <a:avLst/>
@@ -4303,7 +4240,7 @@
                 </a:solidFill>
                 <a:latin typeface="Arial"/>
               </a:rPr>
-              <a:t>Mavjud Muammolar va Taklif Qilinayotgan Tizimli Yechim</a:t>
+              <a:t>Mavjud Muammolar va Taklif Qilinayotgan Aniq Yechim</a:t>
             </a:r>
           </a:p>
           <a:p>
@@ -4319,7 +4256,7 @@
                 </a:solidFill>
                 <a:latin typeface="Arial"/>
               </a:rPr>
-              <a:t>Viloyat maktablaridagi axborot bo‘shliqlarini tezkor va tizimli bartaraf etish</a:t>
+              <a:t>Ortiqcha gaplarsiz: viloyat ta’lim tizimidagi 3 ta asosiy bo‘shliq va ularning tezkor yechimi</a:t>
             </a:r>
           </a:p>
         </p:txBody>
@@ -4441,7 +4378,7 @@
                 </a:solidFill>
                 <a:latin typeface="Arial"/>
               </a:rPr>
-              <a:t>1. AXBOROT OQIMI VA MONITORING NAZORATI</a:t>
+              <a:t>1. AXBOROT OQIMI VA NAZORAT</a:t>
             </a:r>
           </a:p>
           <a:p>
@@ -4466,7 +4403,7 @@
                 </a:solidFill>
                 <a:latin typeface="Arial"/>
               </a:rPr>
-              <a:t>900+ maktabdagi ta’lim holati, yutuqlar va muammolar markazga tarqoq, kechikib va tizimsiz yetib keladi. Yagona tahliliy monitoring bazasi yo‘q.</a:t>
+              <a:t>900+ maktabdagi ta’lim holati va yutuqlar markazga tarqoq va kechikib yetib keladi. Yagona nazorat bazasi mavjud emas.</a:t>
             </a:r>
           </a:p>
           <a:p>
@@ -4482,7 +4419,7 @@
                 </a:solidFill>
                 <a:latin typeface="Arial"/>
               </a:rPr>
-              <a:t>✔  «Focus Media» Yechimi: </a:t>
+              <a:t>✔  Aniq Yechim: </a:t>
             </a:r>
             <a:r>
               <a:rPr sz="950">
@@ -4491,7 +4428,7 @@
                 </a:solidFill>
                 <a:latin typeface="Arial"/>
               </a:rPr>
-              <a:t>Har bir maktab va tuman bo‘yicha yagona markazlashgan elektron axborot oqimi. Rahbariyat har kuni haqqoniy, filtrlangan va tezkor axborotga ega bo‘ladi.</a:t>
+              <a:t>Har bir maktab bo‘yicha yagona markazlashgan elektron axborot oqimi. Rahbariyatga har kuni haqqoniy va saralangan ma’lumot beriladi.</a:t>
             </a:r>
           </a:p>
         </p:txBody>
@@ -4613,7 +4550,7 @@
                 </a:solidFill>
                 <a:latin typeface="Arial"/>
               </a:rPr>
-              <a:t>2. AXBOROT XAVFSIZLIGI VA FEYKLARGA RADDIYA</a:t>
+              <a:t>2. NOTO‘G‘RI XABARLARGA TEZKOR RADDIYA</a:t>
             </a:r>
           </a:p>
           <a:p>
@@ -4638,7 +4575,7 @@
                 </a:solidFill>
                 <a:latin typeface="Arial"/>
               </a:rPr>
-              <a:t>Ijtimoiy tarmoqlardagi feyk xabarlar, asossiz mish-mishlar va salbiy rezonanslarga rasmiy munosabat bildirish 24–48 soatgacha kechikadi.</a:t>
+              <a:t>Ijtimoiy tarmoqlardagi mish-mishlar va noto‘g‘ri xabarlarga rasmiy munosabat bildirish 1-2 kunga cho‘zilib ketadi.</a:t>
             </a:r>
           </a:p>
           <a:p>
@@ -4654,7 +4591,7 @@
                 </a:solidFill>
                 <a:latin typeface="Arial"/>
               </a:rPr>
-              <a:t>✔  «Focus Media» Yechimi: </a:t>
+              <a:t>✔  Aniq Yechim: </a:t>
             </a:r>
             <a:r>
               <a:rPr sz="950">
@@ -4663,7 +4600,7 @@
                 </a:solidFill>
                 <a:latin typeface="Arial"/>
               </a:rPr>
-              <a:t>«Kiber-Qalqon» dasturi va rasmiy tasdiqlangan kanallar orqali 15 daqiqada tezkor rasmiy raddiya va tushuntirish berish mexanizmi joriy etiladi.</a:t>
+              <a:t>«Kiber-Qalqon» tizimi va rasmiy kanallar orqali 15 daqiqada tezkor rasmiy raddiya va tushuntirish beriladi.</a:t>
             </a:r>
           </a:p>
         </p:txBody>
@@ -4785,7 +4722,7 @@
                 </a:solidFill>
                 <a:latin typeface="Arial"/>
               </a:rPr>
-              <a:t>3. VILOYAT YOSHLARI VA USTOZLAR NUFUZI</a:t>
+              <a:t>3. IQTIDORLI YOSHLAR VA FIDOYI USTOZLAR</a:t>
             </a:r>
           </a:p>
           <a:p>
@@ -4810,7 +4747,7 @@
                 </a:solidFill>
                 <a:latin typeface="Arial"/>
               </a:rPr>
-              <a:t>Olimpiada va sport chempionlari, innovatsion o‘quvchilar va ilg‘or pedagog ustozlar faqat o‘z maktabi doirasida tanilib, keng jamoatchilikka ko‘rinmaydi.</a:t>
+              <a:t>Fan olimpiadasi va sport chempionlari, ilg‘or ustozlar faqat o‘z maktabi doirasida qolib, keng ommaga ko‘rinmaydi.</a:t>
             </a:r>
           </a:p>
           <a:p>
@@ -4826,7 +4763,7 @@
                 </a:solidFill>
                 <a:latin typeface="Arial"/>
               </a:rPr>
-              <a:t>✔  «Focus Media» Yechimi: </a:t>
+              <a:t>✔  Aniq Yechim: </a:t>
             </a:r>
             <a:r>
               <a:rPr sz="950">
@@ -4835,7 +4772,7 @@
                 </a:solidFill>
                 <a:latin typeface="Arial"/>
               </a:rPr>
-              <a:t>«Viloyat Iftixorlari» elektron reytingi orqali iqtidorli yoshlar va fidoyi ustozlarni viloyat va respublika miqyosida brend darajasiga ko‘tarish.</a:t>
+              <a:t>«Viloyat Iftixorlari» saralashi orqali iqtidorli o‘quvchilar va fidoyi ustozlarni viloyat va respublika miqyosida tanitish.</a:t>
             </a:r>
           </a:p>
         </p:txBody>
@@ -4912,7 +4849,7 @@
                 </a:solidFill>
                 <a:latin typeface="Arial"/>
               </a:rPr>
-              <a:t>«Focus Media» — Toshkent Viloyati Umumta’lim Maktablari Yagona Raqamli Tizimi</a:t>
+              <a:t>«Focus Media» — Toshkent Viloyati Maktablarining Yagona Raqamli Axborot Tizimi</a:t>
             </a:r>
             <a:r>
               <a:rPr sz="850">
@@ -4921,7 +4858,7 @@
                 </a:solidFill>
                 <a:latin typeface="Arial"/>
               </a:rPr>
-              <a:t>   |   Rasmiy aloqa: @Torabek_Abduvoitov   |   Bot: @focusmedia4_bot</a:t>
+              <a:t>   |   Loyiha tashabbuskori: To‘rabek Abduvoitov (@Torabek_Abduvoitov)   |   Bot: @focusmedia4_bot</a:t>
             </a:r>
             <a:r>
               <a:rPr sz="850" b="1">
@@ -4930,7 +4867,7 @@
                 </a:solidFill>
                 <a:latin typeface="Arial"/>
               </a:rPr>
-              <a:t>   |   Slayd 2 / 5</a:t>
+              <a:t>   |   2 / 5-sahifa</a:t>
             </a:r>
           </a:p>
         </p:txBody>
@@ -5045,7 +4982,7 @@
                 </a:solidFill>
                 <a:latin typeface="Arial"/>
               </a:rPr>
-              <a:t>KONSEPSIYA VA TIZIM ARXITEKTURASI</a:t>
+              <a:t>KONSEPSIYA VA POYDEVOR</a:t>
             </a:r>
           </a:p>
         </p:txBody>
@@ -5059,7 +4996,7 @@
         <p:spPr>
           <a:xfrm>
             <a:off x="731520" y="804672"/>
-            <a:ext cx="10728655" cy="457200"/>
+            <a:ext cx="10728655" cy="502920"/>
           </a:xfrm>
           <a:prstGeom prst="rect">
             <a:avLst/>
@@ -5095,7 +5032,7 @@
                 </a:solidFill>
                 <a:latin typeface="Arial"/>
               </a:rPr>
-              <a:t>Raqamli boshqaruv platformasi, milliy media-kontent portfeli va zamonaviy kasblar</a:t>
+              <a:t>Internetda xavfsizlik, milliy ibratli kontent va yoshlarni bepul kasbga yo‘naltirish</a:t>
             </a:r>
           </a:p>
         </p:txBody>
@@ -5214,7 +5151,7 @@
                 </a:solidFill>
                 <a:latin typeface="Arial"/>
               </a:rPr>
-              <a:t>Har bir maktabning mavjud texnik imkoniyatlari (smartfon, mikrofon, noutbuk) negizida to‘liq avtomatlashtirilgan raqamli media infratuzilmasi shakllantiriladi.</a:t>
+              <a:t>Har bir maktabning mavjud texnik imkoniyatlari (smartfon, noutbuk) asosida to‘liq raqamli media xizmati yo‘lga qo‘yiladi.</a:t>
             </a:r>
           </a:p>
           <a:p>
@@ -5230,8 +5167,8 @@
                 </a:solidFill>
                 <a:latin typeface="Arial"/>
               </a:rPr>
-              <a:t>✔ Qo‘shimcha byudjet talab etilmaydi
-✔ 100% yoshlar amaliy ijodkorligi</a:t>
+              <a:t>✔ Qo‘shimcha byudjet talab etmaydi
+✔ 100% yoshlar amaliy ijodi</a:t>
             </a:r>
           </a:p>
         </p:txBody>
@@ -5353,7 +5290,7 @@
                 </a:solidFill>
                 <a:latin typeface="Arial"/>
               </a:rPr>
-              <a:t>1-USTUN: RAQAMLI IT PLATFORMA &amp; KIBER-XAVFSIZLIK</a:t>
+              <a:t>1-USTUN: RAQAMLI TIZIM VA INTERNET XAVFSIZLIGI</a:t>
             </a:r>
           </a:p>
           <a:p>
@@ -5378,7 +5315,7 @@
                 </a:solidFill>
                 <a:latin typeface="Arial"/>
               </a:rPr>
-              <a:t>24/7 rejimida viloyat yangiliklari, rasmiy dayjestlar va murojaat qabuli.</a:t>
+              <a:t>24/7 rejimida viloyat yangiliklari, sharhlar va murojaat qabuli.</a:t>
             </a:r>
           </a:p>
           <a:p>
@@ -5394,7 +5331,7 @@
                 </a:solidFill>
                 <a:latin typeface="Arial"/>
               </a:rPr>
-              <a:t>● Veb-Monitoring Portali: </a:t>
+              <a:t>● Elektron Tahlil Sahifasi: </a:t>
             </a:r>
             <a:r>
               <a:rPr sz="880">
@@ -5403,7 +5340,7 @@
                 </a:solidFill>
                 <a:latin typeface="Arial"/>
               </a:rPr>
-              <a:t>Viloyat ta’lim boshqarmasi uchun ochiq, shaffof va tahliliy elektron platforma.</a:t>
+              <a:t>Viloyat ta’lim boshqarmasi uchun ochiq, shaffof va tahliliy ma’lumotlar bazasi.</a:t>
             </a:r>
           </a:p>
           <a:p>
@@ -5428,7 +5365,7 @@
                 </a:solidFill>
                 <a:latin typeface="Arial"/>
               </a:rPr>
-              <a:t>Kibergigiyena, shaxsiy ma’lumotlar himoyasi va kiberbulling profilaktikasi.</a:t>
+              <a:t>O‘quvchilar va ota-onalar uchun shaxsiy ma’lumotlarni asrash va internet xavfsizligi.</a:t>
             </a:r>
           </a:p>
         </p:txBody>
@@ -5550,7 +5487,7 @@
                 </a:solidFill>
                 <a:latin typeface="Arial"/>
               </a:rPr>
-              <a:t>2-USTUN: MILLIY MEDIA-KONTENT VA TARG‘IBOT</a:t>
+              <a:t>2-USTUN: MILLIY VA IBRATLI MAZMUN-MUNDARIJA</a:t>
             </a:r>
           </a:p>
           <a:p>
@@ -5566,7 +5503,7 @@
                 </a:solidFill>
                 <a:latin typeface="Arial"/>
               </a:rPr>
-              <a:t>● «Hafta Nigohi» Dayjesti: </a:t>
+              <a:t>● «Hafta Sarasi» Xabarlari: </a:t>
             </a:r>
             <a:r>
               <a:rPr sz="880">
@@ -5575,7 +5512,7 @@
                 </a:solidFill>
                 <a:latin typeface="Arial"/>
               </a:rPr>
-              <a:t>Har hafta viloyat maktablaridagi namunali ochiq darslar va ilmiy yutuqlar sarasi.</a:t>
+              <a:t>Har hafta viloyat maktablaridagi namunali ochiq darslar va yutuqlar sarasi.</a:t>
             </a:r>
           </a:p>
           <a:p>
@@ -5591,7 +5528,7 @@
                 </a:solidFill>
                 <a:latin typeface="Arial"/>
               </a:rPr>
-              <a:t>● «Focus Suhbat» Podkasti: </a:t>
+              <a:t>● «Focus Suhbat» Ovozli Muloqoti: </a:t>
             </a:r>
             <a:r>
               <a:rPr sz="880">
@@ -5600,7 +5537,7 @@
                 </a:solidFill>
                 <a:latin typeface="Arial"/>
               </a:rPr>
-              <a:t>Ziyolilar, faxriy ustozlar va iqtidorli yetakchi o‘quvchilar bilan intervyular.</a:t>
+              <a:t>Tajribali ustozlar va namunali yetakchi o‘quvchilar bilan ibratli suhbatlar.</a:t>
             </a:r>
           </a:p>
           <a:p>
@@ -5616,7 +5553,7 @@
                 </a:solidFill>
                 <a:latin typeface="Arial"/>
               </a:rPr>
-              <a:t>● «Viloyat Iftixorlari» Reytingi: </a:t>
+              <a:t>● «Viloyat Iftixorlari» Saralashi: </a:t>
             </a:r>
             <a:r>
               <a:rPr sz="880">
@@ -5625,7 +5562,7 @@
                 </a:solidFill>
                 <a:latin typeface="Arial"/>
               </a:rPr>
-              <a:t>Xalqaro fan olimpiadalari va sport chempionlarini keng ommalashtirish.</a:t>
+              <a:t>Xalqaro fan va sport chempionlarini viloyat faxriga aylantirish.</a:t>
             </a:r>
           </a:p>
         </p:txBody>
@@ -5747,7 +5684,7 @@
                 </a:solidFill>
                 <a:latin typeface="Arial"/>
               </a:rPr>
-              <a:t>3-USTUN: KAM XARAJATLI STUDIYA &amp; KASBLAR</a:t>
+              <a:t>3-USTUN: TEJAMKOR STUDIYA VA BEPUL KASB-HUNAR</a:t>
             </a:r>
           </a:p>
           <a:p>
@@ -5763,7 +5700,7 @@
                 </a:solidFill>
                 <a:latin typeface="Arial"/>
               </a:rPr>
-              <a:t>● Low-Cost Mobil Studiya Modeli: </a:t>
+              <a:t>● Tejamkor Mobil Studiya: </a:t>
             </a:r>
             <a:r>
               <a:rPr sz="880">
@@ -5772,7 +5709,7 @@
                 </a:solidFill>
                 <a:latin typeface="Arial"/>
               </a:rPr>
-              <a:t>Mavjud smartfon va kompyuterlar negizida maktab media-burchagi.</a:t>
+              <a:t>Mavjud smartfon va kompyuterlar negizida maktab media-burchagi faoliyati.</a:t>
             </a:r>
           </a:p>
           <a:p>
@@ -5797,7 +5734,7 @@
                 </a:solidFill>
                 <a:latin typeface="Arial"/>
               </a:rPr>
-              <a:t>SMM, mobilografiya, montaj va jurnalistika sohalariga bepul o‘qitish.</a:t>
+              <a:t>Ijtimoiy tarmoqlar, video tasvirga olish, montaj va jurnalistika bo‘yicha bepul amaliyot.</a:t>
             </a:r>
           </a:p>
           <a:p>
@@ -5822,7 +5759,7 @@
                 </a:solidFill>
                 <a:latin typeface="Arial"/>
               </a:rPr>
-              <a:t>Maktabning ijobiy imijini yuksaltiruvchi tayyor o‘quvchilar jamoasi.</a:t>
+              <a:t>Maktabning ijobiy nufuzini yuksaltiruvchi tayyor o‘quvchilar jamoasi.</a:t>
             </a:r>
           </a:p>
         </p:txBody>
@@ -5899,7 +5836,7 @@
                 </a:solidFill>
                 <a:latin typeface="Arial"/>
               </a:rPr>
-              <a:t>«Focus Media» — Toshkent Viloyati Umumta’lim Maktablari Yagona Raqamli Tizimi</a:t>
+              <a:t>«Focus Media» — Toshkent Viloyati Maktablarining Yagona Raqamli Axborot Tizimi</a:t>
             </a:r>
             <a:r>
               <a:rPr sz="850">
@@ -5908,7 +5845,7 @@
                 </a:solidFill>
                 <a:latin typeface="Arial"/>
               </a:rPr>
-              <a:t>   |   Rasmiy aloqa: @Torabek_Abduvoitov   |   Bot: @focusmedia4_bot</a:t>
+              <a:t>   |   Loyiha tashabbuskori: To‘rabek Abduvoitov (@Torabek_Abduvoitov)   |   Bot: @focusmedia4_bot</a:t>
             </a:r>
             <a:r>
               <a:rPr sz="850" b="1">
@@ -5917,7 +5854,7 @@
                 </a:solidFill>
                 <a:latin typeface="Arial"/>
               </a:rPr>
-              <a:t>   |   Slayd 3 / 5</a:t>
+              <a:t>   |   3 / 5-sahifa</a:t>
             </a:r>
           </a:p>
         </p:txBody>
@@ -6032,7 +5969,7 @@
                 </a:solidFill>
                 <a:latin typeface="Arial"/>
               </a:rPr>
-              <a:t>TASHKILIY TUZILMA VA IJRO MEXANIZMI</a:t>
+              <a:t>BOSHQARUV VA IJRO MEXANIZMI</a:t>
             </a:r>
           </a:p>
         </p:txBody>
@@ -6046,7 +5983,7 @@
         <p:spPr>
           <a:xfrm>
             <a:off x="731520" y="804672"/>
-            <a:ext cx="10728655" cy="457200"/>
+            <a:ext cx="10728655" cy="502920"/>
           </a:xfrm>
           <a:prstGeom prst="rect">
             <a:avLst/>
@@ -6066,7 +6003,7 @@
                 </a:solidFill>
                 <a:latin typeface="Arial"/>
               </a:rPr>
-              <a:t>Maktab Media Boshqaruvi va 4 Bosqichli Yo‘l Xaritasi</a:t>
+              <a:t>Maktab Media Tuzilmasi va Bosqichma-bosqich Reja</a:t>
             </a:r>
           </a:p>
           <a:p>
@@ -6082,7 +6019,7 @@
                 </a:solidFill>
                 <a:latin typeface="Arial"/>
               </a:rPr>
-              <a:t>Qo‘shimcha shtat talab etmaydigan boshqaruv va viloyat bo‘yicha aniq joriy etish bosqichlari</a:t>
+              <a:t>Qo‘shimcha shtatsiz boshqaruv tuzilmasi va viloyat bo‘yicha tizimli joriy etish yo‘li</a:t>
             </a:r>
           </a:p>
         </p:txBody>
@@ -6204,7 +6141,7 @@
                 </a:solidFill>
                 <a:latin typeface="Arial"/>
               </a:rPr>
-              <a:t>MAKTAB MEDIA GURUHI TUZILMASI (4 BO‘G‘IN)</a:t>
+              <a:t>MAKTAB MEDIA GURUHI (4 BO‘G‘IN)</a:t>
             </a:r>
           </a:p>
           <a:p>
@@ -6220,7 +6157,7 @@
                 </a:solidFill>
                 <a:latin typeface="Arial"/>
               </a:rPr>
-              <a:t>01. Media Koordinator (Mas’ul Rahbar)
+              <a:t>01. Mas’ul Rahbar (Yetakchi)
 </a:t>
             </a:r>
             <a:r>
@@ -6230,7 +6167,7 @@
                 </a:solidFill>
                 <a:latin typeface="Arial"/>
               </a:rPr>
-              <a:t>Yoshlar yetakchisi / Informatika fani o‘qituvchisi. Strategik reja, tuman ta’lim bo‘limi bilan aloqa va IT nazorati.</a:t>
+              <a:t>Yoshlar yetakchisi yoki Informatika ustozi. Rejalashtirish, ta’lim bo‘limi bilan aloqa va umumiy nazorat.</a:t>
             </a:r>
           </a:p>
           <a:p>
@@ -6256,7 +6193,7 @@
                 </a:solidFill>
                 <a:latin typeface="Arial"/>
               </a:rPr>
-              <a:t>2-3 nafar iqtidorli o‘quvchi. Maktab tadbirlarini tezkor tasvirga olish, videolarni dinamik montaj qilish va efirga tayyorlash.</a:t>
+              <a:t>2-3 nafar iqtidorli o‘quvchi. Maktab tadbirlarini tezkor tasvirga olish va videolarni montaj qilish.</a:t>
             </a:r>
           </a:p>
           <a:p>
@@ -6282,7 +6219,7 @@
                 </a:solidFill>
                 <a:latin typeface="Arial"/>
               </a:rPr>
-              <a:t>1-2 nafar havaskor o‘quvchi. Yagona brending asosida rasmiy e’lonlar, posterlar va infografik materiallar tayyorlash.</a:t>
+              <a:t>1-2 nafar o‘quvchi. Rasmiy e’lonlar, posterlar va qulay infografik materiallarni tayyorlash.</a:t>
             </a:r>
           </a:p>
           <a:p>
@@ -6298,7 +6235,7 @@
                 </a:solidFill>
                 <a:latin typeface="Arial"/>
               </a:rPr>
-              <a:t>04. Yosh Jurnalistlar Guruhi
+              <a:t>04. Yosh Qalamkashlar Guruhi
 </a:t>
             </a:r>
             <a:r>
@@ -6308,7 +6245,7 @@
                 </a:solidFill>
                 <a:latin typeface="Arial"/>
               </a:rPr>
-              <a:t>2-3 nafar ijodkor o‘quvchi. Tahliliy maqolalar, ustoz va tengdoshlar bilan intervyular hamda rasmiy xabarlar tayyorlash.</a:t>
+              <a:t>2-3 nafar ijodkor o‘quvchi. Qisqa maqolalar, ustoz va tengdoshlar bilan muloqot hamda xabarlar tayyorlash.</a:t>
             </a:r>
           </a:p>
         </p:txBody>
@@ -6430,7 +6367,7 @@
                 </a:solidFill>
                 <a:latin typeface="Arial"/>
               </a:rPr>
-              <a:t>AMALGA OSHIRISH BOSQICHLARI (YO‘L XARITASI)</a:t>
+              <a:t>AMALGA OSHIRISH REJASI (4 ANIQ BOSQICH)</a:t>
             </a:r>
           </a:p>
           <a:p>
@@ -6446,7 +6383,7 @@
                 </a:solidFill>
                 <a:latin typeface="Arial"/>
               </a:rPr>
-              <a:t>1-BOSQICH: Normativ Asos va Tayanch Maktablar
+              <a:t>1-BOSQICH: Me’yoriy Asos va Tayanch Maktablar
 </a:t>
             </a:r>
             <a:r>
@@ -6456,7 +6393,7 @@
                 </a:solidFill>
                 <a:latin typeface="Arial"/>
               </a:rPr>
-              <a:t>Boshqarma buyrug‘ini qabul qilish va 22 ta tuman/shaharda 1 tadan (jami 22 ta) tayanch pilot maktablarini belgilash hamda mas’ullarni tayinlash.</a:t>
+              <a:t>Boshqarma buyrug‘ini qabul qilish hamda 22 ta tuman va shaharda 1 tadan (jami 22 ta) namunali tayanch maktabini belgilash.</a:t>
             </a:r>
           </a:p>
           <a:p>
@@ -6472,7 +6409,7 @@
                 </a:solidFill>
                 <a:latin typeface="Arial"/>
               </a:rPr>
-              <a:t>2-BOSQICH: O‘quv-Amaliy Master-Klasslar va Brandbook
+              <a:t>2-BOSQICH: Amaliy O‘quv va Yagona Standartlar
 </a:t>
             </a:r>
             <a:r>
@@ -6482,7 +6419,7 @@
                 </a:solidFill>
                 <a:latin typeface="Arial"/>
               </a:rPr>
-              <a:t>22 ta tayanch maktab media guruhlari uchun 3 kunlik intensiv master-klasslar o‘tkazish, yagona «Focus Media Brandbook» standartlarini tarqatish.</a:t>
+              <a:t>22 ta tayanch maktab media guruhlari uchun 3 kunlik qisqa amaliy o‘quv o‘tkazish va yagona me’yorlarni tarqatish.</a:t>
             </a:r>
           </a:p>
           <a:p>
@@ -6498,7 +6435,7 @@
                 </a:solidFill>
                 <a:latin typeface="Arial"/>
               </a:rPr>
-              <a:t>3-BOSQICH: Texnologik Integratsiya va «Focus Bot»
+              <a:t>3-BOSQICH: Raqamli Tizim va «Focus Bot»
 </a:t>
             </a:r>
             <a:r>
@@ -6508,7 +6445,7 @@
                 </a:solidFill>
                 <a:latin typeface="Arial"/>
               </a:rPr>
-              <a:t>«Focus Bot» va elektron platformani ishga tushirish, haftalik «Hafta Nigohi» tahliliy dayjestlarini efirga berish hamda «Kiber-Qalqon» tizimini darslarga bog‘lash.</a:t>
+              <a:t>«Focus Bot» va elektron sahifani to‘liq ishga tushirish, haftalik tahliliy xabarlarni uzatish va «Kiber-Qalqon» tizimini ulash.</a:t>
             </a:r>
           </a:p>
           <a:p>
@@ -6524,7 +6461,7 @@
                 </a:solidFill>
                 <a:latin typeface="Arial"/>
               </a:rPr>
-              <a:t>4-BOSQICH: Viloyat Bo‘ylab To‘liq Qamrov va Reyting
+              <a:t>4-BOSQICH: Viloyat Bo‘yicha To‘liq Qamrov
 </a:t>
             </a:r>
             <a:r>
@@ -6534,7 +6471,7 @@
                 </a:solidFill>
                 <a:latin typeface="Arial"/>
               </a:rPr>
-              <a:t>Tizimni viloyatdagi 900+ maktabga tatbiq etish, har oy yakuni bo‘yicha «Eng Faol Maktab Media Markazi» reytingini e’lon qilish va yillik Forum o‘tkazish.</a:t>
+              <a:t>Tizimni viloyatdagi barcha 900+ maktabga tatbiq etish, har oy yakuni bo‘yicha natijalar saralashini chiqarish va Viloyat Anjumanini o‘tkazish.</a:t>
             </a:r>
           </a:p>
         </p:txBody>
@@ -6611,7 +6548,7 @@
                 </a:solidFill>
                 <a:latin typeface="Arial"/>
               </a:rPr>
-              <a:t>«Focus Media» — Toshkent Viloyati Umumta’lim Maktablari Yagona Raqamli Tizimi</a:t>
+              <a:t>«Focus Media» — Toshkent Viloyati Maktablarining Yagona Raqamli Axborot Tizimi</a:t>
             </a:r>
             <a:r>
               <a:rPr sz="850">
@@ -6620,7 +6557,7 @@
                 </a:solidFill>
                 <a:latin typeface="Arial"/>
               </a:rPr>
-              <a:t>   |   Rasmiy aloqa: @Torabek_Abduvoitov   |   Bot: @focusmedia4_bot</a:t>
+              <a:t>   |   Loyiha tashabbuskori: To‘rabek Abduvoitov (@Torabek_Abduvoitov)   |   Bot: @focusmedia4_bot</a:t>
             </a:r>
             <a:r>
               <a:rPr sz="850" b="1">
@@ -6629,7 +6566,7 @@
                 </a:solidFill>
                 <a:latin typeface="Arial"/>
               </a:rPr>
-              <a:t>   |   Slayd 4 / 5</a:t>
+              <a:t>   |   4 / 5-sahifa</a:t>
             </a:r>
           </a:p>
         </p:txBody>
@@ -6744,7 +6681,7 @@
                 </a:solidFill>
                 <a:latin typeface="Arial"/>
               </a:rPr>
-              <a:t>NATIJADORLIK VA STRATEGIK SAMARADORLIK</a:t>
+              <a:t>SAMARADORLIK VA ASOSIY FOYDA</a:t>
             </a:r>
           </a:p>
         </p:txBody>
@@ -6758,7 +6695,7 @@
         <p:spPr>
           <a:xfrm>
             <a:off x="731520" y="804672"/>
-            <a:ext cx="10728655" cy="457200"/>
+            <a:ext cx="10728655" cy="502920"/>
           </a:xfrm>
           <a:prstGeom prst="rect">
             <a:avLst/>
@@ -6778,7 +6715,7 @@
                 </a:solidFill>
                 <a:latin typeface="Arial"/>
               </a:rPr>
-              <a:t>Kutilayotgan Natijalar (KPI) va Rahbariyat Uchun Asosiy Foyda</a:t>
+              <a:t>Kutilayotgan Natijalar va Rahbariyat Uchun Asosiy Foyda</a:t>
             </a:r>
           </a:p>
           <a:p>
@@ -6794,7 +6731,7 @@
                 </a:solidFill>
                 <a:latin typeface="Arial"/>
               </a:rPr>
-              <a:t>Toshkent viloyati ta’lim tizimida o‘lchanadigan aniq ko‘rsatkichlar va erishiladigan natijalar</a:t>
+              <a:t>Viloyat ta’lim tizimida erishiladigan aniq ko‘rsatkichlar va strategik yutuqlar</a:t>
             </a:r>
           </a:p>
         </p:txBody>
@@ -6904,7 +6841,7 @@
                 </a:solidFill>
                 <a:latin typeface="Arial"/>
               </a:rPr>
-              <a:t>Viloyatning barcha 22 ta tuman va shahri (900+ maktab) yagona axborot tizimiga ulanadi.</a:t>
+              <a:t>Viloyatning barcha 22 ta tuman va shahri (900+ maktab) yagona tizimga ulanadi.</a:t>
             </a:r>
           </a:p>
         </p:txBody>
@@ -7033,7 +6970,7 @@
                 </a:solidFill>
                 <a:latin typeface="Arial"/>
               </a:rPr>
-              <a:t>Ijtimoiy tarmoqlardagi feyk va mish-mishlarga rasmiy tezkor munosabat bildirish vaqti.</a:t>
+              <a:t>Ijtimoiy tarmoqlardagi mish-mish va yolg‘on xabarlarga rasmiy javob berish vaqti.</a:t>
             </a:r>
           </a:p>
         </p:txBody>
@@ -7130,7 +7067,7 @@
                 </a:solidFill>
                 <a:latin typeface="Arial"/>
               </a:rPr>
-              <a:t>5,000+ O‘quvchi</a:t>
+              <a:t>5,000+ Yoshlar</a:t>
             </a:r>
           </a:p>
           <a:p>
@@ -7162,7 +7099,7 @@
                 </a:solidFill>
                 <a:latin typeface="Arial"/>
               </a:rPr>
-              <a:t>SMM, mobilografiya, montaj va jurnalistika kabi zamonaviy kasblarga bepul o‘qitiladi.</a:t>
+              <a:t>Ijtimoiy tarmoqlar, tasvirga olish, montaj va jurnalistikaga bepul o‘qitiladi.</a:t>
             </a:r>
           </a:p>
         </p:txBody>
@@ -7291,7 +7228,7 @@
                 </a:solidFill>
                 <a:latin typeface="Arial"/>
               </a:rPr>
-              <a:t>Qo‘shimcha shtat talab etmaydi; maktablarning mavjud infratuzilmasi hisobiga ishlaydi.</a:t>
+              <a:t>Qo‘shimcha shtat talab etmaydi; maktablarning mavjud texnik bazasi hisobiga ishlaydi.</a:t>
             </a:r>
           </a:p>
         </p:txBody>
@@ -7388,7 +7325,7 @@
                 </a:solidFill>
                 <a:latin typeface="Arial"/>
               </a:rPr>
-              <a:t>✔  NAZORAT VA SHAFFOFLIK</a:t>
+              <a:t>✔  DOIMIY NAZORAT VA SHAFFOFLIK</a:t>
             </a:r>
           </a:p>
           <a:p>
@@ -7404,7 +7341,7 @@
                 </a:solidFill>
                 <a:latin typeface="Arial"/>
               </a:rPr>
-              <a:t>Har bir tuman va maktabdagi real ta’lim sifati, o‘quvchilar yutuqlari hamda muammolari bo‘yicha viloyat rahbariyatiga har kuni haqqoniy va filtrlangan axborot oqimi kafolatlanadi.</a:t>
+              <a:t>Har bir maktabdagi ta’lim sifati, o‘quvchilar yutuqlari va muammolari bo‘yicha viloyat rahbariyatiga har kuni haqqoniy va saralangan axborot oqimi kafolatlanadi.</a:t>
             </a:r>
           </a:p>
         </p:txBody>
@@ -7517,7 +7454,7 @@
                 </a:solidFill>
                 <a:latin typeface="Arial"/>
               </a:rPr>
-              <a:t>Xalqaro va respublika fan olimpiadalari g‘oliblari, chempionlar va ilg‘or fidoyi ustozlar respublika miqyosida brendga aylantirilib, viloyatning ijobiy imiji mustahkamlanadi.</a:t>
+              <a:t>Olimpiada g‘oliblari, sport chempionlari va fidoyi ustozlar viloyat va respublika miqyosida e’tirof etilib, viloyatning nufuzi mustahkamlanadi.</a:t>
             </a:r>
           </a:p>
         </p:txBody>
@@ -7614,7 +7551,7 @@
                 </a:solidFill>
                 <a:latin typeface="Arial"/>
               </a:rPr>
-              <a:t>✔  RAQAMLI IMMUNITET VA XAVFSIZLIK</a:t>
+              <a:t>✔  INTERNETDA XAVFSIZLIK VA SOG‘LOM MUHIT</a:t>
             </a:r>
           </a:p>
           <a:p>
@@ -7630,7 +7567,7 @@
                 </a:solidFill>
                 <a:latin typeface="Arial"/>
               </a:rPr>
-              <a:t>«Kiber-Qalqon» dasturi orqali o‘quvchi va ota-onalar kiberxavflar, fishing va yot g‘oyalardan himoyalanadi. Viloyat maktablarida mustahkam axborot madaniyati shakllanadi.</a:t>
+              <a:t>«Kiber-Qalqon» dasturi orqali o‘quvchilar va ota-onalar internetdagi xavflar, firibgarlik va yot g‘oyalardan mustahkam himoyalanadi.</a:t>
             </a:r>
           </a:p>
         </p:txBody>
@@ -7727,7 +7664,7 @@
                 </a:solidFill>
                 <a:latin typeface="Arial"/>
               </a:rPr>
-              <a:t>«Focus Media — bu shunchaki axborot kanali emas, balki Toshkent viloyati yoshlarining intellektual salohiyati, vatanparvarligi va zamonaviy imijini namoyon etuvchi raqamli ko‘zgudir!»</a:t>
+              <a:t>«Focus Media — Toshkent viloyati yoshlarining intellektual salohiyati va zamonaviy qiyofasini namoyon etuvchi raqamli ko‘zgudir!»</a:t>
             </a:r>
           </a:p>
           <a:p>
@@ -7743,7 +7680,7 @@
                 </a:solidFill>
                 <a:latin typeface="Arial"/>
               </a:rPr>
-              <a:t>Loyiha Tashabbuskori: To‘rabek Abduvoitov   |   Telegram: @Torabek_Abduvoitov   |   Bot: @focusmedia4_bot   |   Portal: focus-media-toshkent.vercel.app</a:t>
+              <a:t>Loyiha Tashabbuskori: To‘rabek Abduvoitov   |   Telegram: @Torabek_Abduvoitov   |   Bot: @focusmedia4_bot   |   Sahifa: focus-media-toshkent.vercel.app</a:t>
             </a:r>
           </a:p>
         </p:txBody>
@@ -7820,7 +7757,7 @@
                 </a:solidFill>
                 <a:latin typeface="Arial"/>
               </a:rPr>
-              <a:t>«Focus Media» — Toshkent Viloyati Umumta’lim Maktablari Yagona Raqamli Tizimi</a:t>
+              <a:t>«Focus Media» — Toshkent Viloyati Maktablarining Yagona Raqamli Axborot Tizimi</a:t>
             </a:r>
             <a:r>
               <a:rPr sz="850">
@@ -7829,7 +7766,7 @@
                 </a:solidFill>
                 <a:latin typeface="Arial"/>
               </a:rPr>
-              <a:t>   |   Rasmiy aloqa: @Torabek_Abduvoitov   |   Bot: @focusmedia4_bot</a:t>
+              <a:t>   |   Loyiha tashabbuskori: To‘rabek Abduvoitov (@Torabek_Abduvoitov)   |   Bot: @focusmedia4_bot</a:t>
             </a:r>
             <a:r>
               <a:rPr sz="850" b="1">
@@ -7838,7 +7775,7 @@
                 </a:solidFill>
                 <a:latin typeface="Arial"/>
               </a:rPr>
-              <a:t>   |   Slayd 5 / 5</a:t>
+              <a:t>   |   5 / 5-sahifa</a:t>
             </a:r>
           </a:p>
         </p:txBody>

</xml_diff>

<commit_message>
Refine: Perfect pixel alignment and pure Uzbek phrasing across presentation and web
</commit_message>
<xml_diff>
--- a/Focus_Media_Toshkent_Viloyati_5_Slayd.pptx
+++ b/Focus_Media_Toshkent_Viloyati_5_Slayd.pptx
@@ -3143,8 +3143,8 @@
         </p:nvSpPr>
         <p:spPr>
           <a:xfrm>
-            <a:off x="731520" y="548640"/>
-            <a:ext cx="2286000" cy="292608"/>
+            <a:off x="731520" y="411480"/>
+            <a:ext cx="2194560" cy="274320"/>
           </a:xfrm>
           <a:prstGeom prst="roundRect">
             <a:avLst/>
@@ -3197,8 +3197,8 @@
         </p:nvSpPr>
         <p:spPr>
           <a:xfrm>
-            <a:off x="731520" y="960120"/>
-            <a:ext cx="8046720" cy="1051560"/>
+            <a:off x="731520" y="777240"/>
+            <a:ext cx="8046720" cy="1371600"/>
           </a:xfrm>
           <a:prstGeom prst="rect">
             <a:avLst/>
@@ -3212,33 +3212,39 @@
           <a:lstStyle/>
           <a:p>
             <a:r>
-              <a:rPr sz="3400" b="1">
+              <a:rPr sz="3000" b="1">
                 <a:solidFill>
                   <a:srgbClr val="1E3A8A"/>
                 </a:solidFill>
                 <a:latin typeface="Arial"/>
               </a:rPr>
               <a:t>«FOCUS MEDIA»</a:t>
-            </a:r>
-            <a:r>
-              <a:rPr sz="1600" b="1">
-                <a:solidFill>
-                  <a:srgbClr val="2563EB"/>
-                </a:solidFill>
-                <a:latin typeface="Arial"/>
-              </a:rPr>
-              <a:t>
-Toshkent viloyati umumta’lim maktablarining yagona raqamli tizimi</a:t>
             </a:r>
           </a:p>
           <a:p>
             <a:pPr>
               <a:spcBef>
-                <a:spcPts val="400"/>
+                <a:spcPts val="200"/>
               </a:spcBef>
             </a:pPr>
             <a:r>
-              <a:rPr sz="1050">
+              <a:rPr sz="1400" b="1">
+                <a:solidFill>
+                  <a:srgbClr val="2563EB"/>
+                </a:solidFill>
+                <a:latin typeface="Arial"/>
+              </a:rPr>
+              <a:t>Toshkent viloyati umumta’lim maktablarining yagona raqamli tizimi</a:t>
+            </a:r>
+          </a:p>
+          <a:p>
+            <a:pPr>
+              <a:spcBef>
+                <a:spcPts val="300"/>
+              </a:spcBef>
+            </a:pPr>
+            <a:r>
+              <a:rPr sz="1000">
                 <a:solidFill>
                   <a:srgbClr val="64748B"/>
                 </a:solidFill>
@@ -3257,7 +3263,7 @@
         </p:nvSpPr>
         <p:spPr>
           <a:xfrm>
-            <a:off x="9144000" y="502920"/>
+            <a:off x="9144000" y="411480"/>
             <a:ext cx="2316175" cy="2316175"/>
           </a:xfrm>
           <a:prstGeom prst="roundRect">
@@ -3310,7 +3316,7 @@
         </p:blipFill>
         <p:spPr>
           <a:xfrm>
-            <a:off x="9253728" y="612648"/>
+            <a:off x="9253728" y="521207"/>
             <a:ext cx="2093976" cy="2093976"/>
           </a:xfrm>
           <a:prstGeom prst="rect">
@@ -3326,8 +3332,8 @@
         </p:nvSpPr>
         <p:spPr>
           <a:xfrm>
-            <a:off x="731520" y="2194560"/>
-            <a:ext cx="8046720" cy="1143000"/>
+            <a:off x="731520" y="2331720"/>
+            <a:ext cx="8046720" cy="1051560"/>
           </a:xfrm>
           <a:prstGeom prst="roundRect">
             <a:avLst/>
@@ -3335,9 +3341,9 @@
           <a:solidFill>
             <a:srgbClr val="F8FAFC"/>
           </a:solidFill>
-          <a:ln w="12700">
+          <a:ln w="19050">
             <a:solidFill>
-              <a:srgbClr val="E2E8F0"/>
+              <a:srgbClr val="2563EB"/>
             </a:solidFill>
           </a:ln>
         </p:spPr>
@@ -3356,7 +3362,7 @@
           </a:fontRef>
         </p:style>
         <p:txBody>
-          <a:bodyPr rtlCol="0" anchor="ctr" wrap="square" lIns="274320" tIns="137160" rIns="228600" bIns="109728"/>
+          <a:bodyPr rtlCol="0" anchor="ctr" wrap="square" lIns="228600" tIns="137160" rIns="228600" bIns="109728"/>
           <a:lstStyle/>
           <a:p>
             <a:pPr algn="ctr"/>
@@ -3377,7 +3383,7 @@
               </a:spcBef>
             </a:pPr>
             <a:r>
-              <a:rPr sz="1200" b="1">
+              <a:rPr sz="1150" b="1">
                 <a:solidFill>
                   <a:srgbClr val="0F172A"/>
                 </a:solidFill>
@@ -3390,57 +3396,14 @@
       </p:sp>
       <p:sp>
         <p:nvSpPr>
-          <p:cNvPr id="8" name="Rectangle 7"/>
+          <p:cNvPr id="8" name="Rounded Rectangle 7"/>
           <p:cNvSpPr/>
           <p:nvPr/>
         </p:nvSpPr>
         <p:spPr>
           <a:xfrm>
-            <a:off x="731520" y="2194560"/>
-            <a:ext cx="91440" cy="1143000"/>
-          </a:xfrm>
-          <a:prstGeom prst="rect">
-            <a:avLst/>
-          </a:prstGeom>
-          <a:solidFill>
-            <a:srgbClr val="2563EB"/>
-          </a:solidFill>
-          <a:ln>
-            <a:noFill/>
-          </a:ln>
-        </p:spPr>
-        <p:style>
-          <a:lnRef idx="1">
-            <a:schemeClr val="accent1"/>
-          </a:lnRef>
-          <a:fillRef idx="3">
-            <a:schemeClr val="accent1"/>
-          </a:fillRef>
-          <a:effectRef idx="2">
-            <a:schemeClr val="accent1"/>
-          </a:effectRef>
-          <a:fontRef idx="minor">
-            <a:schemeClr val="lt1"/>
-          </a:fontRef>
-        </p:style>
-        <p:txBody>
-          <a:bodyPr rtlCol="0" anchor="ctr"/>
-          <a:lstStyle/>
-          <a:p>
-            <a:pPr algn="ctr"/>
-          </a:p>
-        </p:txBody>
-      </p:sp>
-      <p:sp>
-        <p:nvSpPr>
-          <p:cNvPr id="9" name="Rounded Rectangle 8"/>
-          <p:cNvSpPr/>
-          <p:nvPr/>
-        </p:nvSpPr>
-        <p:spPr>
-          <a:xfrm>
-            <a:off x="731520" y="3520440"/>
-            <a:ext cx="2542032" cy="1691640"/>
+            <a:off x="731520" y="3566160"/>
+            <a:ext cx="2542032" cy="1737360"/>
           </a:xfrm>
           <a:prstGeom prst="roundRect">
             <a:avLst/>
@@ -3448,9 +3411,9 @@
           <a:solidFill>
             <a:srgbClr val="F8FAFC"/>
           </a:solidFill>
-          <a:ln w="12700">
+          <a:ln w="19050">
             <a:solidFill>
-              <a:srgbClr val="E2E8F0"/>
+              <a:srgbClr val="1E3A8A"/>
             </a:solidFill>
           </a:ln>
         </p:spPr>
@@ -3486,26 +3449,26 @@
           <a:p>
             <a:pPr>
               <a:spcBef>
+                <a:spcPts val="600"/>
+              </a:spcBef>
+            </a:pPr>
+            <a:r>
+              <a:rPr sz="1300" b="1">
+                <a:solidFill>
+                  <a:srgbClr val="0F172A"/>
+                </a:solidFill>
+                <a:latin typeface="Arial"/>
+              </a:rPr>
+              <a:t>22 Ta Tuman / Shahar</a:t>
+            </a:r>
+          </a:p>
+          <a:p>
+            <a:pPr>
+              <a:spcBef>
                 <a:spcPts val="500"/>
               </a:spcBef>
             </a:pPr>
             <a:r>
-              <a:rPr sz="1300" b="1">
-                <a:solidFill>
-                  <a:srgbClr val="0F172A"/>
-                </a:solidFill>
-                <a:latin typeface="Arial"/>
-              </a:rPr>
-              <a:t>22 Ta Tuman / Shahar</a:t>
-            </a:r>
-          </a:p>
-          <a:p>
-            <a:pPr>
-              <a:spcBef>
-                <a:spcPts val="400"/>
-              </a:spcBef>
-            </a:pPr>
-            <a:r>
               <a:rPr sz="900">
                 <a:solidFill>
                   <a:srgbClr val="64748B"/>
@@ -3519,57 +3482,14 @@
       </p:sp>
       <p:sp>
         <p:nvSpPr>
-          <p:cNvPr id="10" name="Rectangle 9"/>
+          <p:cNvPr id="9" name="Rounded Rectangle 8"/>
           <p:cNvSpPr/>
           <p:nvPr/>
         </p:nvSpPr>
         <p:spPr>
           <a:xfrm>
-            <a:off x="731520" y="3520440"/>
-            <a:ext cx="2542032" cy="54864"/>
-          </a:xfrm>
-          <a:prstGeom prst="rect">
-            <a:avLst/>
-          </a:prstGeom>
-          <a:solidFill>
-            <a:srgbClr val="1E3A8A"/>
-          </a:solidFill>
-          <a:ln>
-            <a:noFill/>
-          </a:ln>
-        </p:spPr>
-        <p:style>
-          <a:lnRef idx="1">
-            <a:schemeClr val="accent1"/>
-          </a:lnRef>
-          <a:fillRef idx="3">
-            <a:schemeClr val="accent1"/>
-          </a:fillRef>
-          <a:effectRef idx="2">
-            <a:schemeClr val="accent1"/>
-          </a:effectRef>
-          <a:fontRef idx="minor">
-            <a:schemeClr val="lt1"/>
-          </a:fontRef>
-        </p:style>
-        <p:txBody>
-          <a:bodyPr rtlCol="0" anchor="ctr"/>
-          <a:lstStyle/>
-          <a:p>
-            <a:pPr algn="ctr"/>
-          </a:p>
-        </p:txBody>
-      </p:sp>
-      <p:sp>
-        <p:nvSpPr>
-          <p:cNvPr id="11" name="Rounded Rectangle 10"/>
-          <p:cNvSpPr/>
-          <p:nvPr/>
-        </p:nvSpPr>
-        <p:spPr>
-          <a:xfrm>
-            <a:off x="3456432" y="3520440"/>
-            <a:ext cx="2542032" cy="1691640"/>
+            <a:off x="3456432" y="3566160"/>
+            <a:ext cx="2542032" cy="1737360"/>
           </a:xfrm>
           <a:prstGeom prst="roundRect">
             <a:avLst/>
@@ -3577,9 +3497,9 @@
           <a:solidFill>
             <a:srgbClr val="F8FAFC"/>
           </a:solidFill>
-          <a:ln w="12700">
+          <a:ln w="19050">
             <a:solidFill>
-              <a:srgbClr val="E2E8F0"/>
+              <a:srgbClr val="2563EB"/>
             </a:solidFill>
           </a:ln>
         </p:spPr>
@@ -3615,26 +3535,26 @@
           <a:p>
             <a:pPr>
               <a:spcBef>
+                <a:spcPts val="600"/>
+              </a:spcBef>
+            </a:pPr>
+            <a:r>
+              <a:rPr sz="1300" b="1">
+                <a:solidFill>
+                  <a:srgbClr val="0F172A"/>
+                </a:solidFill>
+                <a:latin typeface="Arial"/>
+              </a:rPr>
+              <a:t>500,000+ Ishtirokchi</a:t>
+            </a:r>
+          </a:p>
+          <a:p>
+            <a:pPr>
+              <a:spcBef>
                 <a:spcPts val="500"/>
               </a:spcBef>
             </a:pPr>
             <a:r>
-              <a:rPr sz="1300" b="1">
-                <a:solidFill>
-                  <a:srgbClr val="0F172A"/>
-                </a:solidFill>
-                <a:latin typeface="Arial"/>
-              </a:rPr>
-              <a:t>500,000+ Ishtirokchi</a:t>
-            </a:r>
-          </a:p>
-          <a:p>
-            <a:pPr>
-              <a:spcBef>
-                <a:spcPts val="400"/>
-              </a:spcBef>
-            </a:pPr>
-            <a:r>
               <a:rPr sz="900">
                 <a:solidFill>
                   <a:srgbClr val="64748B"/>
@@ -3648,57 +3568,14 @@
       </p:sp>
       <p:sp>
         <p:nvSpPr>
-          <p:cNvPr id="12" name="Rectangle 11"/>
+          <p:cNvPr id="10" name="Rounded Rectangle 9"/>
           <p:cNvSpPr/>
           <p:nvPr/>
         </p:nvSpPr>
         <p:spPr>
           <a:xfrm>
-            <a:off x="3456432" y="3520440"/>
-            <a:ext cx="2542032" cy="54864"/>
-          </a:xfrm>
-          <a:prstGeom prst="rect">
-            <a:avLst/>
-          </a:prstGeom>
-          <a:solidFill>
-            <a:srgbClr val="2563EB"/>
-          </a:solidFill>
-          <a:ln>
-            <a:noFill/>
-          </a:ln>
-        </p:spPr>
-        <p:style>
-          <a:lnRef idx="1">
-            <a:schemeClr val="accent1"/>
-          </a:lnRef>
-          <a:fillRef idx="3">
-            <a:schemeClr val="accent1"/>
-          </a:fillRef>
-          <a:effectRef idx="2">
-            <a:schemeClr val="accent1"/>
-          </a:effectRef>
-          <a:fontRef idx="minor">
-            <a:schemeClr val="lt1"/>
-          </a:fontRef>
-        </p:style>
-        <p:txBody>
-          <a:bodyPr rtlCol="0" anchor="ctr"/>
-          <a:lstStyle/>
-          <a:p>
-            <a:pPr algn="ctr"/>
-          </a:p>
-        </p:txBody>
-      </p:sp>
-      <p:sp>
-        <p:nvSpPr>
-          <p:cNvPr id="13" name="Rounded Rectangle 12"/>
-          <p:cNvSpPr/>
-          <p:nvPr/>
-        </p:nvSpPr>
-        <p:spPr>
-          <a:xfrm>
-            <a:off x="6181344" y="3520440"/>
-            <a:ext cx="2542032" cy="1691640"/>
+            <a:off x="6181344" y="3566160"/>
+            <a:ext cx="2542032" cy="1737360"/>
           </a:xfrm>
           <a:prstGeom prst="roundRect">
             <a:avLst/>
@@ -3706,9 +3583,9 @@
           <a:solidFill>
             <a:srgbClr val="F8FAFC"/>
           </a:solidFill>
-          <a:ln w="12700">
+          <a:ln w="19050">
             <a:solidFill>
-              <a:srgbClr val="E2E8F0"/>
+              <a:srgbClr val="059669"/>
             </a:solidFill>
           </a:ln>
         </p:spPr>
@@ -3744,26 +3621,26 @@
           <a:p>
             <a:pPr>
               <a:spcBef>
+                <a:spcPts val="600"/>
+              </a:spcBef>
+            </a:pPr>
+            <a:r>
+              <a:rPr sz="1300" b="1">
+                <a:solidFill>
+                  <a:srgbClr val="0F172A"/>
+                </a:solidFill>
+                <a:latin typeface="Arial"/>
+              </a:rPr>
+              <a:t>0 So‘m (Tejamkor)</a:t>
+            </a:r>
+          </a:p>
+          <a:p>
+            <a:pPr>
+              <a:spcBef>
                 <a:spcPts val="500"/>
               </a:spcBef>
             </a:pPr>
             <a:r>
-              <a:rPr sz="1300" b="1">
-                <a:solidFill>
-                  <a:srgbClr val="0F172A"/>
-                </a:solidFill>
-                <a:latin typeface="Arial"/>
-              </a:rPr>
-              <a:t>0 So‘m (Tejamkor)</a:t>
-            </a:r>
-          </a:p>
-          <a:p>
-            <a:pPr>
-              <a:spcBef>
-                <a:spcPts val="400"/>
-              </a:spcBef>
-            </a:pPr>
-            <a:r>
               <a:rPr sz="900">
                 <a:solidFill>
                   <a:srgbClr val="64748B"/>
@@ -3777,57 +3654,14 @@
       </p:sp>
       <p:sp>
         <p:nvSpPr>
-          <p:cNvPr id="14" name="Rectangle 13"/>
+          <p:cNvPr id="11" name="Rounded Rectangle 10"/>
           <p:cNvSpPr/>
           <p:nvPr/>
         </p:nvSpPr>
         <p:spPr>
           <a:xfrm>
-            <a:off x="6181344" y="3520440"/>
-            <a:ext cx="2542032" cy="54864"/>
-          </a:xfrm>
-          <a:prstGeom prst="rect">
-            <a:avLst/>
-          </a:prstGeom>
-          <a:solidFill>
-            <a:srgbClr val="059669"/>
-          </a:solidFill>
-          <a:ln>
-            <a:noFill/>
-          </a:ln>
-        </p:spPr>
-        <p:style>
-          <a:lnRef idx="1">
-            <a:schemeClr val="accent1"/>
-          </a:lnRef>
-          <a:fillRef idx="3">
-            <a:schemeClr val="accent1"/>
-          </a:fillRef>
-          <a:effectRef idx="2">
-            <a:schemeClr val="accent1"/>
-          </a:effectRef>
-          <a:fontRef idx="minor">
-            <a:schemeClr val="lt1"/>
-          </a:fontRef>
-        </p:style>
-        <p:txBody>
-          <a:bodyPr rtlCol="0" anchor="ctr"/>
-          <a:lstStyle/>
-          <a:p>
-            <a:pPr algn="ctr"/>
-          </a:p>
-        </p:txBody>
-      </p:sp>
-      <p:sp>
-        <p:nvSpPr>
-          <p:cNvPr id="15" name="Rounded Rectangle 14"/>
-          <p:cNvSpPr/>
-          <p:nvPr/>
-        </p:nvSpPr>
-        <p:spPr>
-          <a:xfrm>
-            <a:off x="8906256" y="3520440"/>
-            <a:ext cx="2542032" cy="1691640"/>
+            <a:off x="8906256" y="3566160"/>
+            <a:ext cx="2542032" cy="1737360"/>
           </a:xfrm>
           <a:prstGeom prst="roundRect">
             <a:avLst/>
@@ -3835,9 +3669,9 @@
           <a:solidFill>
             <a:srgbClr val="F8FAFC"/>
           </a:solidFill>
-          <a:ln w="12700">
+          <a:ln w="19050">
             <a:solidFill>
-              <a:srgbClr val="E2E8F0"/>
+              <a:srgbClr val="D97706"/>
             </a:solidFill>
           </a:ln>
         </p:spPr>
@@ -3873,26 +3707,26 @@
           <a:p>
             <a:pPr>
               <a:spcBef>
+                <a:spcPts val="600"/>
+              </a:spcBef>
+            </a:pPr>
+            <a:r>
+              <a:rPr sz="1300" b="1">
+                <a:solidFill>
+                  <a:srgbClr val="0F172A"/>
+                </a:solidFill>
+                <a:latin typeface="Arial"/>
+              </a:rPr>
+              <a:t>4 Bosqichda</a:t>
+            </a:r>
+          </a:p>
+          <a:p>
+            <a:pPr>
+              <a:spcBef>
                 <a:spcPts val="500"/>
               </a:spcBef>
             </a:pPr>
             <a:r>
-              <a:rPr sz="1300" b="1">
-                <a:solidFill>
-                  <a:srgbClr val="0F172A"/>
-                </a:solidFill>
-                <a:latin typeface="Arial"/>
-              </a:rPr>
-              <a:t>4 Bosqichda</a:t>
-            </a:r>
-          </a:p>
-          <a:p>
-            <a:pPr>
-              <a:spcBef>
-                <a:spcPts val="400"/>
-              </a:spcBef>
-            </a:pPr>
-            <a:r>
               <a:rPr sz="900">
                 <a:solidFill>
                   <a:srgbClr val="64748B"/>
@@ -3906,57 +3740,14 @@
       </p:sp>
       <p:sp>
         <p:nvSpPr>
-          <p:cNvPr id="16" name="Rectangle 15"/>
+          <p:cNvPr id="12" name="Rounded Rectangle 11"/>
           <p:cNvSpPr/>
           <p:nvPr/>
         </p:nvSpPr>
         <p:spPr>
           <a:xfrm>
-            <a:off x="8906256" y="3520440"/>
-            <a:ext cx="2542032" cy="54864"/>
-          </a:xfrm>
-          <a:prstGeom prst="rect">
-            <a:avLst/>
-          </a:prstGeom>
-          <a:solidFill>
-            <a:srgbClr val="D97706"/>
-          </a:solidFill>
-          <a:ln>
-            <a:noFill/>
-          </a:ln>
-        </p:spPr>
-        <p:style>
-          <a:lnRef idx="1">
-            <a:schemeClr val="accent1"/>
-          </a:lnRef>
-          <a:fillRef idx="3">
-            <a:schemeClr val="accent1"/>
-          </a:fillRef>
-          <a:effectRef idx="2">
-            <a:schemeClr val="accent1"/>
-          </a:effectRef>
-          <a:fontRef idx="minor">
-            <a:schemeClr val="lt1"/>
-          </a:fontRef>
-        </p:style>
-        <p:txBody>
-          <a:bodyPr rtlCol="0" anchor="ctr"/>
-          <a:lstStyle/>
-          <a:p>
-            <a:pPr algn="ctr"/>
-          </a:p>
-        </p:txBody>
-      </p:sp>
-      <p:sp>
-        <p:nvSpPr>
-          <p:cNvPr id="17" name="Rounded Rectangle 16"/>
-          <p:cNvSpPr/>
-          <p:nvPr/>
-        </p:nvSpPr>
-        <p:spPr>
-          <a:xfrm>
-            <a:off x="731520" y="5440680"/>
-            <a:ext cx="10728655" cy="658368"/>
+            <a:off x="731520" y="5486400"/>
+            <a:ext cx="10728655" cy="621792"/>
           </a:xfrm>
           <a:prstGeom prst="roundRect">
             <a:avLst/>
@@ -3985,7 +3776,7 @@
           </a:fontRef>
         </p:style>
         <p:txBody>
-          <a:bodyPr rtlCol="0" anchor="ctr" wrap="square" lIns="228600" tIns="137160" rIns="228600" bIns="91440"/>
+          <a:bodyPr rtlCol="0" anchor="ctr" wrap="square" lIns="228600" tIns="128016" rIns="228600" bIns="91440"/>
           <a:lstStyle/>
           <a:p>
             <a:pPr algn="ctr"/>
@@ -4003,13 +3794,13 @@
       </p:sp>
       <p:sp>
         <p:nvSpPr>
-          <p:cNvPr id="18" name="Rectangle 17"/>
+          <p:cNvPr id="13" name="Rectangle 12"/>
           <p:cNvSpPr/>
           <p:nvPr/>
         </p:nvSpPr>
         <p:spPr>
           <a:xfrm>
-            <a:off x="731520" y="6309360"/>
+            <a:off x="731520" y="6327648"/>
             <a:ext cx="10728655" cy="13716"/>
           </a:xfrm>
           <a:prstGeom prst="rect">
@@ -4046,7 +3837,7 @@
       </p:sp>
       <p:sp>
         <p:nvSpPr>
-          <p:cNvPr id="19" name="TextBox 18"/>
+          <p:cNvPr id="14" name="TextBox 13"/>
           <p:cNvSpPr txBox="1"/>
           <p:nvPr/>
         </p:nvSpPr>
@@ -4165,8 +3956,8 @@
         </p:nvSpPr>
         <p:spPr>
           <a:xfrm>
-            <a:off x="731520" y="438912"/>
-            <a:ext cx="2926080" cy="292608"/>
+            <a:off x="731520" y="384048"/>
+            <a:ext cx="2743200" cy="274320"/>
           </a:xfrm>
           <a:prstGeom prst="roundRect">
             <a:avLst/>
@@ -4219,8 +4010,8 @@
         </p:nvSpPr>
         <p:spPr>
           <a:xfrm>
-            <a:off x="731520" y="804672"/>
-            <a:ext cx="10728655" cy="502920"/>
+            <a:off x="731520" y="713232"/>
+            <a:ext cx="10728655" cy="594360"/>
           </a:xfrm>
           <a:prstGeom prst="rect">
             <a:avLst/>
@@ -4269,7 +4060,7 @@
         </p:nvSpPr>
         <p:spPr>
           <a:xfrm>
-            <a:off x="731520" y="1463040"/>
+            <a:off x="731520" y="1417320"/>
             <a:ext cx="10728655" cy="1508760"/>
           </a:xfrm>
           <a:prstGeom prst="roundRect">
@@ -4278,9 +4069,9 @@
           <a:solidFill>
             <a:srgbClr val="F8FAFC"/>
           </a:solidFill>
-          <a:ln w="12700">
+          <a:ln w="19050">
             <a:solidFill>
-              <a:srgbClr val="E2E8F0"/>
+              <a:srgbClr val="1E3A8A"/>
             </a:solidFill>
           </a:ln>
         </p:spPr>
@@ -4308,57 +4099,14 @@
       </p:sp>
       <p:sp>
         <p:nvSpPr>
-          <p:cNvPr id="6" name="Rectangle 5"/>
-          <p:cNvSpPr/>
-          <p:nvPr/>
-        </p:nvSpPr>
-        <p:spPr>
-          <a:xfrm>
-            <a:off x="731520" y="1463040"/>
-            <a:ext cx="91440" cy="1508760"/>
-          </a:xfrm>
-          <a:prstGeom prst="rect">
-            <a:avLst/>
-          </a:prstGeom>
-          <a:solidFill>
-            <a:srgbClr val="1E3A8A"/>
-          </a:solidFill>
-          <a:ln>
-            <a:noFill/>
-          </a:ln>
-        </p:spPr>
-        <p:style>
-          <a:lnRef idx="1">
-            <a:schemeClr val="accent1"/>
-          </a:lnRef>
-          <a:fillRef idx="3">
-            <a:schemeClr val="accent1"/>
-          </a:fillRef>
-          <a:effectRef idx="2">
-            <a:schemeClr val="accent1"/>
-          </a:effectRef>
-          <a:fontRef idx="minor">
-            <a:schemeClr val="lt1"/>
-          </a:fontRef>
-        </p:style>
-        <p:txBody>
-          <a:bodyPr rtlCol="0" anchor="ctr"/>
-          <a:lstStyle/>
-          <a:p>
-            <a:pPr algn="ctr"/>
-          </a:p>
-        </p:txBody>
-      </p:sp>
-      <p:sp>
-        <p:nvSpPr>
-          <p:cNvPr id="7" name="TextBox 6"/>
+          <p:cNvPr id="6" name="TextBox 5"/>
           <p:cNvSpPr txBox="1"/>
           <p:nvPr/>
         </p:nvSpPr>
         <p:spPr>
           <a:xfrm>
-            <a:off x="960120" y="1554480"/>
-            <a:ext cx="10332720" cy="1325880"/>
+            <a:off x="960120" y="1527048"/>
+            <a:ext cx="10241280" cy="1289304"/>
           </a:xfrm>
           <a:prstGeom prst="rect">
             <a:avLst/>
@@ -4372,7 +4120,7 @@
           <a:lstStyle/>
           <a:p>
             <a:r>
-              <a:rPr sz="1100" b="1">
+              <a:rPr sz="1150" b="1">
                 <a:solidFill>
                   <a:srgbClr val="1E3A8A"/>
                 </a:solidFill>
@@ -4384,11 +4132,11 @@
           <a:p>
             <a:pPr>
               <a:spcBef>
-                <a:spcPts val="400"/>
+                <a:spcPts val="600"/>
               </a:spcBef>
             </a:pPr>
             <a:r>
-              <a:rPr sz="950" b="1">
+              <a:rPr sz="1000" b="1">
                 <a:solidFill>
                   <a:srgbClr val="E11D48"/>
                 </a:solidFill>
@@ -4397,7 +4145,7 @@
               <a:t>✖  Mavjud Muammo: </a:t>
             </a:r>
             <a:r>
-              <a:rPr sz="950">
+              <a:rPr sz="1000">
                 <a:solidFill>
                   <a:srgbClr val="334155"/>
                 </a:solidFill>
@@ -4409,11 +4157,11 @@
           <a:p>
             <a:pPr>
               <a:spcBef>
-                <a:spcPts val="300"/>
+                <a:spcPts val="500"/>
               </a:spcBef>
             </a:pPr>
             <a:r>
-              <a:rPr sz="950" b="1">
+              <a:rPr sz="1000" b="1">
                 <a:solidFill>
                   <a:srgbClr val="059669"/>
                 </a:solidFill>
@@ -4422,7 +4170,7 @@
               <a:t>✔  Aniq Yechim: </a:t>
             </a:r>
             <a:r>
-              <a:rPr sz="950">
+              <a:rPr sz="1000">
                 <a:solidFill>
                   <a:srgbClr val="0F172A"/>
                 </a:solidFill>
@@ -4435,13 +4183,13 @@
       </p:sp>
       <p:sp>
         <p:nvSpPr>
-          <p:cNvPr id="8" name="Rounded Rectangle 7"/>
+          <p:cNvPr id="7" name="Rounded Rectangle 6"/>
           <p:cNvSpPr/>
           <p:nvPr/>
         </p:nvSpPr>
         <p:spPr>
           <a:xfrm>
-            <a:off x="731520" y="3081528"/>
+            <a:off x="731520" y="3054096"/>
             <a:ext cx="10728655" cy="1508760"/>
           </a:xfrm>
           <a:prstGeom prst="roundRect">
@@ -4450,9 +4198,9 @@
           <a:solidFill>
             <a:srgbClr val="F8FAFC"/>
           </a:solidFill>
-          <a:ln w="12700">
+          <a:ln w="19050">
             <a:solidFill>
-              <a:srgbClr val="E2E8F0"/>
+              <a:srgbClr val="E11D48"/>
             </a:solidFill>
           </a:ln>
         </p:spPr>
@@ -4480,57 +4228,14 @@
       </p:sp>
       <p:sp>
         <p:nvSpPr>
-          <p:cNvPr id="9" name="Rectangle 8"/>
-          <p:cNvSpPr/>
-          <p:nvPr/>
-        </p:nvSpPr>
-        <p:spPr>
-          <a:xfrm>
-            <a:off x="731520" y="3081528"/>
-            <a:ext cx="91440" cy="1508760"/>
-          </a:xfrm>
-          <a:prstGeom prst="rect">
-            <a:avLst/>
-          </a:prstGeom>
-          <a:solidFill>
-            <a:srgbClr val="E11D48"/>
-          </a:solidFill>
-          <a:ln>
-            <a:noFill/>
-          </a:ln>
-        </p:spPr>
-        <p:style>
-          <a:lnRef idx="1">
-            <a:schemeClr val="accent1"/>
-          </a:lnRef>
-          <a:fillRef idx="3">
-            <a:schemeClr val="accent1"/>
-          </a:fillRef>
-          <a:effectRef idx="2">
-            <a:schemeClr val="accent1"/>
-          </a:effectRef>
-          <a:fontRef idx="minor">
-            <a:schemeClr val="lt1"/>
-          </a:fontRef>
-        </p:style>
-        <p:txBody>
-          <a:bodyPr rtlCol="0" anchor="ctr"/>
-          <a:lstStyle/>
-          <a:p>
-            <a:pPr algn="ctr"/>
-          </a:p>
-        </p:txBody>
-      </p:sp>
-      <p:sp>
-        <p:nvSpPr>
-          <p:cNvPr id="10" name="TextBox 9"/>
+          <p:cNvPr id="8" name="TextBox 7"/>
           <p:cNvSpPr txBox="1"/>
           <p:nvPr/>
         </p:nvSpPr>
         <p:spPr>
           <a:xfrm>
-            <a:off x="960120" y="3172968"/>
-            <a:ext cx="10332720" cy="1325880"/>
+            <a:off x="960120" y="3163824"/>
+            <a:ext cx="10241280" cy="1289304"/>
           </a:xfrm>
           <a:prstGeom prst="rect">
             <a:avLst/>
@@ -4544,7 +4249,7 @@
           <a:lstStyle/>
           <a:p>
             <a:r>
-              <a:rPr sz="1100" b="1">
+              <a:rPr sz="1150" b="1">
                 <a:solidFill>
                   <a:srgbClr val="E11D48"/>
                 </a:solidFill>
@@ -4556,11 +4261,11 @@
           <a:p>
             <a:pPr>
               <a:spcBef>
-                <a:spcPts val="400"/>
+                <a:spcPts val="600"/>
               </a:spcBef>
             </a:pPr>
             <a:r>
-              <a:rPr sz="950" b="1">
+              <a:rPr sz="1000" b="1">
                 <a:solidFill>
                   <a:srgbClr val="E11D48"/>
                 </a:solidFill>
@@ -4569,7 +4274,7 @@
               <a:t>✖  Mavjud Muammo: </a:t>
             </a:r>
             <a:r>
-              <a:rPr sz="950">
+              <a:rPr sz="1000">
                 <a:solidFill>
                   <a:srgbClr val="334155"/>
                 </a:solidFill>
@@ -4581,11 +4286,11 @@
           <a:p>
             <a:pPr>
               <a:spcBef>
-                <a:spcPts val="300"/>
+                <a:spcPts val="500"/>
               </a:spcBef>
             </a:pPr>
             <a:r>
-              <a:rPr sz="950" b="1">
+              <a:rPr sz="1000" b="1">
                 <a:solidFill>
                   <a:srgbClr val="059669"/>
                 </a:solidFill>
@@ -4594,7 +4299,7 @@
               <a:t>✔  Aniq Yechim: </a:t>
             </a:r>
             <a:r>
-              <a:rPr sz="950">
+              <a:rPr sz="1000">
                 <a:solidFill>
                   <a:srgbClr val="0F172A"/>
                 </a:solidFill>
@@ -4607,13 +4312,13 @@
       </p:sp>
       <p:sp>
         <p:nvSpPr>
-          <p:cNvPr id="11" name="Rounded Rectangle 10"/>
+          <p:cNvPr id="9" name="Rounded Rectangle 8"/>
           <p:cNvSpPr/>
           <p:nvPr/>
         </p:nvSpPr>
         <p:spPr>
           <a:xfrm>
-            <a:off x="731520" y="4700016"/>
+            <a:off x="731520" y="4690872"/>
             <a:ext cx="10728655" cy="1508760"/>
           </a:xfrm>
           <a:prstGeom prst="roundRect">
@@ -4622,9 +4327,9 @@
           <a:solidFill>
             <a:srgbClr val="F8FAFC"/>
           </a:solidFill>
-          <a:ln w="12700">
+          <a:ln w="19050">
             <a:solidFill>
-              <a:srgbClr val="E2E8F0"/>
+              <a:srgbClr val="059669"/>
             </a:solidFill>
           </a:ln>
         </p:spPr>
@@ -4652,57 +4357,14 @@
       </p:sp>
       <p:sp>
         <p:nvSpPr>
-          <p:cNvPr id="12" name="Rectangle 11"/>
-          <p:cNvSpPr/>
-          <p:nvPr/>
-        </p:nvSpPr>
-        <p:spPr>
-          <a:xfrm>
-            <a:off x="731520" y="4700016"/>
-            <a:ext cx="91440" cy="1508760"/>
-          </a:xfrm>
-          <a:prstGeom prst="rect">
-            <a:avLst/>
-          </a:prstGeom>
-          <a:solidFill>
-            <a:srgbClr val="059669"/>
-          </a:solidFill>
-          <a:ln>
-            <a:noFill/>
-          </a:ln>
-        </p:spPr>
-        <p:style>
-          <a:lnRef idx="1">
-            <a:schemeClr val="accent1"/>
-          </a:lnRef>
-          <a:fillRef idx="3">
-            <a:schemeClr val="accent1"/>
-          </a:fillRef>
-          <a:effectRef idx="2">
-            <a:schemeClr val="accent1"/>
-          </a:effectRef>
-          <a:fontRef idx="minor">
-            <a:schemeClr val="lt1"/>
-          </a:fontRef>
-        </p:style>
-        <p:txBody>
-          <a:bodyPr rtlCol="0" anchor="ctr"/>
-          <a:lstStyle/>
-          <a:p>
-            <a:pPr algn="ctr"/>
-          </a:p>
-        </p:txBody>
-      </p:sp>
-      <p:sp>
-        <p:nvSpPr>
-          <p:cNvPr id="13" name="TextBox 12"/>
+          <p:cNvPr id="10" name="TextBox 9"/>
           <p:cNvSpPr txBox="1"/>
           <p:nvPr/>
         </p:nvSpPr>
         <p:spPr>
           <a:xfrm>
-            <a:off x="960120" y="4791456"/>
-            <a:ext cx="10332720" cy="1325880"/>
+            <a:off x="960120" y="4800600"/>
+            <a:ext cx="10241280" cy="1289304"/>
           </a:xfrm>
           <a:prstGeom prst="rect">
             <a:avLst/>
@@ -4716,7 +4378,7 @@
           <a:lstStyle/>
           <a:p>
             <a:r>
-              <a:rPr sz="1100" b="1">
+              <a:rPr sz="1150" b="1">
                 <a:solidFill>
                   <a:srgbClr val="059669"/>
                 </a:solidFill>
@@ -4728,11 +4390,11 @@
           <a:p>
             <a:pPr>
               <a:spcBef>
-                <a:spcPts val="400"/>
+                <a:spcPts val="600"/>
               </a:spcBef>
             </a:pPr>
             <a:r>
-              <a:rPr sz="950" b="1">
+              <a:rPr sz="1000" b="1">
                 <a:solidFill>
                   <a:srgbClr val="E11D48"/>
                 </a:solidFill>
@@ -4741,7 +4403,7 @@
               <a:t>✖  Mavjud Muammo: </a:t>
             </a:r>
             <a:r>
-              <a:rPr sz="950">
+              <a:rPr sz="1000">
                 <a:solidFill>
                   <a:srgbClr val="334155"/>
                 </a:solidFill>
@@ -4753,11 +4415,11 @@
           <a:p>
             <a:pPr>
               <a:spcBef>
-                <a:spcPts val="300"/>
+                <a:spcPts val="500"/>
               </a:spcBef>
             </a:pPr>
             <a:r>
-              <a:rPr sz="950" b="1">
+              <a:rPr sz="1000" b="1">
                 <a:solidFill>
                   <a:srgbClr val="059669"/>
                 </a:solidFill>
@@ -4766,7 +4428,7 @@
               <a:t>✔  Aniq Yechim: </a:t>
             </a:r>
             <a:r>
-              <a:rPr sz="950">
+              <a:rPr sz="1000">
                 <a:solidFill>
                   <a:srgbClr val="0F172A"/>
                 </a:solidFill>
@@ -4779,13 +4441,13 @@
       </p:sp>
       <p:sp>
         <p:nvSpPr>
-          <p:cNvPr id="14" name="Rectangle 13"/>
+          <p:cNvPr id="11" name="Rectangle 10"/>
           <p:cNvSpPr/>
           <p:nvPr/>
         </p:nvSpPr>
         <p:spPr>
           <a:xfrm>
-            <a:off x="731520" y="6309360"/>
+            <a:off x="731520" y="6327648"/>
             <a:ext cx="10728655" cy="13716"/>
           </a:xfrm>
           <a:prstGeom prst="rect">
@@ -4822,7 +4484,7 @@
       </p:sp>
       <p:sp>
         <p:nvSpPr>
-          <p:cNvPr id="15" name="TextBox 14"/>
+          <p:cNvPr id="12" name="TextBox 11"/>
           <p:cNvSpPr txBox="1"/>
           <p:nvPr/>
         </p:nvSpPr>
@@ -4941,8 +4603,8 @@
         </p:nvSpPr>
         <p:spPr>
           <a:xfrm>
-            <a:off x="731520" y="438912"/>
-            <a:ext cx="2926080" cy="292608"/>
+            <a:off x="731520" y="384048"/>
+            <a:ext cx="2743200" cy="274320"/>
           </a:xfrm>
           <a:prstGeom prst="roundRect">
             <a:avLst/>
@@ -4995,8 +4657,8 @@
         </p:nvSpPr>
         <p:spPr>
           <a:xfrm>
-            <a:off x="731520" y="804672"/>
-            <a:ext cx="10728655" cy="502920"/>
+            <a:off x="731520" y="713232"/>
+            <a:ext cx="10728655" cy="594360"/>
           </a:xfrm>
           <a:prstGeom prst="rect">
             <a:avLst/>
@@ -5045,8 +4707,8 @@
         </p:nvSpPr>
         <p:spPr>
           <a:xfrm>
-            <a:off x="7772400" y="1463040"/>
-            <a:ext cx="3687775" cy="4617720"/>
+            <a:off x="7772400" y="1417320"/>
+            <a:ext cx="3687775" cy="4709160"/>
           </a:xfrm>
           <a:prstGeom prst="roundRect">
             <a:avLst/>
@@ -5098,7 +4760,7 @@
         </p:blipFill>
         <p:spPr>
           <a:xfrm>
-            <a:off x="7863840" y="1554480"/>
+            <a:off x="7863840" y="1508760"/>
             <a:ext cx="3504895" cy="1956816"/>
           </a:xfrm>
           <a:prstGeom prst="rect">
@@ -5115,7 +4777,7 @@
         <p:spPr>
           <a:xfrm>
             <a:off x="7909560" y="3611880"/>
-            <a:ext cx="3413455" cy="2286000"/>
+            <a:ext cx="3413455" cy="2377440"/>
           </a:xfrm>
           <a:prstGeom prst="rect">
             <a:avLst/>
@@ -5181,8 +4843,8 @@
         </p:nvSpPr>
         <p:spPr>
           <a:xfrm>
-            <a:off x="731520" y="1463040"/>
-            <a:ext cx="6858000" cy="1444752"/>
+            <a:off x="731520" y="1417320"/>
+            <a:ext cx="6858000" cy="1463040"/>
           </a:xfrm>
           <a:prstGeom prst="roundRect">
             <a:avLst/>
@@ -5190,9 +4852,9 @@
           <a:solidFill>
             <a:srgbClr val="F8FAFC"/>
           </a:solidFill>
-          <a:ln w="12700">
+          <a:ln w="19050">
             <a:solidFill>
-              <a:srgbClr val="E2E8F0"/>
+              <a:srgbClr val="1E3A8A"/>
             </a:solidFill>
           </a:ln>
         </p:spPr>
@@ -5220,57 +4882,14 @@
       </p:sp>
       <p:sp>
         <p:nvSpPr>
-          <p:cNvPr id="9" name="Rectangle 8"/>
-          <p:cNvSpPr/>
-          <p:nvPr/>
-        </p:nvSpPr>
-        <p:spPr>
-          <a:xfrm>
-            <a:off x="731520" y="1463040"/>
-            <a:ext cx="73152" cy="1444752"/>
-          </a:xfrm>
-          <a:prstGeom prst="rect">
-            <a:avLst/>
-          </a:prstGeom>
-          <a:solidFill>
-            <a:srgbClr val="1E3A8A"/>
-          </a:solidFill>
-          <a:ln>
-            <a:noFill/>
-          </a:ln>
-        </p:spPr>
-        <p:style>
-          <a:lnRef idx="1">
-            <a:schemeClr val="accent1"/>
-          </a:lnRef>
-          <a:fillRef idx="3">
-            <a:schemeClr val="accent1"/>
-          </a:fillRef>
-          <a:effectRef idx="2">
-            <a:schemeClr val="accent1"/>
-          </a:effectRef>
-          <a:fontRef idx="minor">
-            <a:schemeClr val="lt1"/>
-          </a:fontRef>
-        </p:style>
-        <p:txBody>
-          <a:bodyPr rtlCol="0" anchor="ctr"/>
-          <a:lstStyle/>
-          <a:p>
-            <a:pPr algn="ctr"/>
-          </a:p>
-        </p:txBody>
-      </p:sp>
-      <p:sp>
-        <p:nvSpPr>
-          <p:cNvPr id="10" name="TextBox 9"/>
+          <p:cNvPr id="9" name="TextBox 8"/>
           <p:cNvSpPr txBox="1"/>
           <p:nvPr/>
         </p:nvSpPr>
         <p:spPr>
           <a:xfrm>
-            <a:off x="914400" y="1554480"/>
-            <a:ext cx="6583680" cy="1261872"/>
+            <a:off x="914400" y="1527048"/>
+            <a:ext cx="6583680" cy="1243584"/>
           </a:xfrm>
           <a:prstGeom prst="rect">
             <a:avLst/>
@@ -5372,14 +4991,14 @@
       </p:sp>
       <p:sp>
         <p:nvSpPr>
-          <p:cNvPr id="11" name="Rounded Rectangle 10"/>
+          <p:cNvPr id="10" name="Rounded Rectangle 9"/>
           <p:cNvSpPr/>
           <p:nvPr/>
         </p:nvSpPr>
         <p:spPr>
           <a:xfrm>
-            <a:off x="731520" y="3044952"/>
-            <a:ext cx="6858000" cy="1444752"/>
+            <a:off x="731520" y="3017520"/>
+            <a:ext cx="6858000" cy="1463040"/>
           </a:xfrm>
           <a:prstGeom prst="roundRect">
             <a:avLst/>
@@ -5387,9 +5006,9 @@
           <a:solidFill>
             <a:srgbClr val="F8FAFC"/>
           </a:solidFill>
-          <a:ln w="12700">
+          <a:ln w="19050">
             <a:solidFill>
-              <a:srgbClr val="E2E8F0"/>
+              <a:srgbClr val="2563EB"/>
             </a:solidFill>
           </a:ln>
         </p:spPr>
@@ -5417,57 +5036,14 @@
       </p:sp>
       <p:sp>
         <p:nvSpPr>
-          <p:cNvPr id="12" name="Rectangle 11"/>
-          <p:cNvSpPr/>
-          <p:nvPr/>
-        </p:nvSpPr>
-        <p:spPr>
-          <a:xfrm>
-            <a:off x="731520" y="3044952"/>
-            <a:ext cx="73152" cy="1444752"/>
-          </a:xfrm>
-          <a:prstGeom prst="rect">
-            <a:avLst/>
-          </a:prstGeom>
-          <a:solidFill>
-            <a:srgbClr val="2563EB"/>
-          </a:solidFill>
-          <a:ln>
-            <a:noFill/>
-          </a:ln>
-        </p:spPr>
-        <p:style>
-          <a:lnRef idx="1">
-            <a:schemeClr val="accent1"/>
-          </a:lnRef>
-          <a:fillRef idx="3">
-            <a:schemeClr val="accent1"/>
-          </a:fillRef>
-          <a:effectRef idx="2">
-            <a:schemeClr val="accent1"/>
-          </a:effectRef>
-          <a:fontRef idx="minor">
-            <a:schemeClr val="lt1"/>
-          </a:fontRef>
-        </p:style>
-        <p:txBody>
-          <a:bodyPr rtlCol="0" anchor="ctr"/>
-          <a:lstStyle/>
-          <a:p>
-            <a:pPr algn="ctr"/>
-          </a:p>
-        </p:txBody>
-      </p:sp>
-      <p:sp>
-        <p:nvSpPr>
-          <p:cNvPr id="13" name="TextBox 12"/>
+          <p:cNvPr id="11" name="TextBox 10"/>
           <p:cNvSpPr txBox="1"/>
           <p:nvPr/>
         </p:nvSpPr>
         <p:spPr>
           <a:xfrm>
-            <a:off x="914400" y="3136392"/>
-            <a:ext cx="6583680" cy="1261872"/>
+            <a:off x="914400" y="3127248"/>
+            <a:ext cx="6583680" cy="1243584"/>
           </a:xfrm>
           <a:prstGeom prst="rect">
             <a:avLst/>
@@ -5569,14 +5145,14 @@
       </p:sp>
       <p:sp>
         <p:nvSpPr>
-          <p:cNvPr id="14" name="Rounded Rectangle 13"/>
+          <p:cNvPr id="12" name="Rounded Rectangle 11"/>
           <p:cNvSpPr/>
           <p:nvPr/>
         </p:nvSpPr>
         <p:spPr>
           <a:xfrm>
-            <a:off x="731520" y="4626864"/>
-            <a:ext cx="6858000" cy="1444752"/>
+            <a:off x="731520" y="4617720"/>
+            <a:ext cx="6858000" cy="1463040"/>
           </a:xfrm>
           <a:prstGeom prst="roundRect">
             <a:avLst/>
@@ -5584,9 +5160,9 @@
           <a:solidFill>
             <a:srgbClr val="F8FAFC"/>
           </a:solidFill>
-          <a:ln w="12700">
+          <a:ln w="19050">
             <a:solidFill>
-              <a:srgbClr val="E2E8F0"/>
+              <a:srgbClr val="0E7490"/>
             </a:solidFill>
           </a:ln>
         </p:spPr>
@@ -5614,57 +5190,14 @@
       </p:sp>
       <p:sp>
         <p:nvSpPr>
-          <p:cNvPr id="15" name="Rectangle 14"/>
-          <p:cNvSpPr/>
-          <p:nvPr/>
-        </p:nvSpPr>
-        <p:spPr>
-          <a:xfrm>
-            <a:off x="731520" y="4626864"/>
-            <a:ext cx="73152" cy="1444752"/>
-          </a:xfrm>
-          <a:prstGeom prst="rect">
-            <a:avLst/>
-          </a:prstGeom>
-          <a:solidFill>
-            <a:srgbClr val="0E7490"/>
-          </a:solidFill>
-          <a:ln>
-            <a:noFill/>
-          </a:ln>
-        </p:spPr>
-        <p:style>
-          <a:lnRef idx="1">
-            <a:schemeClr val="accent1"/>
-          </a:lnRef>
-          <a:fillRef idx="3">
-            <a:schemeClr val="accent1"/>
-          </a:fillRef>
-          <a:effectRef idx="2">
-            <a:schemeClr val="accent1"/>
-          </a:effectRef>
-          <a:fontRef idx="minor">
-            <a:schemeClr val="lt1"/>
-          </a:fontRef>
-        </p:style>
-        <p:txBody>
-          <a:bodyPr rtlCol="0" anchor="ctr"/>
-          <a:lstStyle/>
-          <a:p>
-            <a:pPr algn="ctr"/>
-          </a:p>
-        </p:txBody>
-      </p:sp>
-      <p:sp>
-        <p:nvSpPr>
-          <p:cNvPr id="16" name="TextBox 15"/>
+          <p:cNvPr id="13" name="TextBox 12"/>
           <p:cNvSpPr txBox="1"/>
           <p:nvPr/>
         </p:nvSpPr>
         <p:spPr>
           <a:xfrm>
-            <a:off x="914400" y="4718304"/>
-            <a:ext cx="6583680" cy="1261872"/>
+            <a:off x="914400" y="4727448"/>
+            <a:ext cx="6583680" cy="1243584"/>
           </a:xfrm>
           <a:prstGeom prst="rect">
             <a:avLst/>
@@ -5766,13 +5299,13 @@
       </p:sp>
       <p:sp>
         <p:nvSpPr>
-          <p:cNvPr id="17" name="Rectangle 16"/>
+          <p:cNvPr id="14" name="Rectangle 13"/>
           <p:cNvSpPr/>
           <p:nvPr/>
         </p:nvSpPr>
         <p:spPr>
           <a:xfrm>
-            <a:off x="731520" y="6309360"/>
+            <a:off x="731520" y="6327648"/>
             <a:ext cx="10728655" cy="13716"/>
           </a:xfrm>
           <a:prstGeom prst="rect">
@@ -5809,7 +5342,7 @@
       </p:sp>
       <p:sp>
         <p:nvSpPr>
-          <p:cNvPr id="18" name="TextBox 17"/>
+          <p:cNvPr id="15" name="TextBox 14"/>
           <p:cNvSpPr txBox="1"/>
           <p:nvPr/>
         </p:nvSpPr>
@@ -5928,8 +5461,8 @@
         </p:nvSpPr>
         <p:spPr>
           <a:xfrm>
-            <a:off x="731520" y="438912"/>
-            <a:ext cx="2926080" cy="292608"/>
+            <a:off x="731520" y="384048"/>
+            <a:ext cx="2743200" cy="274320"/>
           </a:xfrm>
           <a:prstGeom prst="roundRect">
             <a:avLst/>
@@ -5982,8 +5515,8 @@
         </p:nvSpPr>
         <p:spPr>
           <a:xfrm>
-            <a:off x="731520" y="804672"/>
-            <a:ext cx="10728655" cy="502920"/>
+            <a:off x="731520" y="713232"/>
+            <a:ext cx="10728655" cy="594360"/>
           </a:xfrm>
           <a:prstGeom prst="rect">
             <a:avLst/>
@@ -6032,8 +5565,8 @@
         </p:nvSpPr>
         <p:spPr>
           <a:xfrm>
-            <a:off x="731520" y="1463040"/>
-            <a:ext cx="5257800" cy="4617720"/>
+            <a:off x="731520" y="1417320"/>
+            <a:ext cx="5257800" cy="4709160"/>
           </a:xfrm>
           <a:prstGeom prst="roundRect">
             <a:avLst/>
@@ -6041,9 +5574,9 @@
           <a:solidFill>
             <a:srgbClr val="F8FAFC"/>
           </a:solidFill>
-          <a:ln w="12700">
+          <a:ln w="19050">
             <a:solidFill>
-              <a:srgbClr val="E2E8F0"/>
+              <a:srgbClr val="1E3A8A"/>
             </a:solidFill>
           </a:ln>
         </p:spPr>
@@ -6071,57 +5604,14 @@
       </p:sp>
       <p:sp>
         <p:nvSpPr>
-          <p:cNvPr id="6" name="Rectangle 5"/>
-          <p:cNvSpPr/>
-          <p:nvPr/>
-        </p:nvSpPr>
-        <p:spPr>
-          <a:xfrm>
-            <a:off x="731520" y="1463040"/>
-            <a:ext cx="5257800" cy="73152"/>
-          </a:xfrm>
-          <a:prstGeom prst="rect">
-            <a:avLst/>
-          </a:prstGeom>
-          <a:solidFill>
-            <a:srgbClr val="1E3A8A"/>
-          </a:solidFill>
-          <a:ln>
-            <a:noFill/>
-          </a:ln>
-        </p:spPr>
-        <p:style>
-          <a:lnRef idx="1">
-            <a:schemeClr val="accent1"/>
-          </a:lnRef>
-          <a:fillRef idx="3">
-            <a:schemeClr val="accent1"/>
-          </a:fillRef>
-          <a:effectRef idx="2">
-            <a:schemeClr val="accent1"/>
-          </a:effectRef>
-          <a:fontRef idx="minor">
-            <a:schemeClr val="lt1"/>
-          </a:fontRef>
-        </p:style>
-        <p:txBody>
-          <a:bodyPr rtlCol="0" anchor="ctr"/>
-          <a:lstStyle/>
-          <a:p>
-            <a:pPr algn="ctr"/>
-          </a:p>
-        </p:txBody>
-      </p:sp>
-      <p:sp>
-        <p:nvSpPr>
-          <p:cNvPr id="7" name="TextBox 6"/>
+          <p:cNvPr id="6" name="TextBox 5"/>
           <p:cNvSpPr txBox="1"/>
           <p:nvPr/>
         </p:nvSpPr>
         <p:spPr>
           <a:xfrm>
-            <a:off x="960120" y="1645920"/>
-            <a:ext cx="4800600" cy="4297680"/>
+            <a:off x="1097280" y="1691640"/>
+            <a:ext cx="4526280" cy="4251960"/>
           </a:xfrm>
           <a:prstGeom prst="rect">
             <a:avLst/>
@@ -6147,7 +5637,7 @@
           <a:p>
             <a:pPr>
               <a:spcBef>
-                <a:spcPts val="1200"/>
+                <a:spcPts val="1000"/>
               </a:spcBef>
             </a:pPr>
             <a:r>
@@ -6173,7 +5663,7 @@
           <a:p>
             <a:pPr>
               <a:spcBef>
-                <a:spcPts val="1200"/>
+                <a:spcPts val="1000"/>
               </a:spcBef>
             </a:pPr>
             <a:r>
@@ -6199,7 +5689,7 @@
           <a:p>
             <a:pPr>
               <a:spcBef>
-                <a:spcPts val="1200"/>
+                <a:spcPts val="1000"/>
               </a:spcBef>
             </a:pPr>
             <a:r>
@@ -6225,7 +5715,7 @@
           <a:p>
             <a:pPr>
               <a:spcBef>
-                <a:spcPts val="1200"/>
+                <a:spcPts val="1000"/>
               </a:spcBef>
             </a:pPr>
             <a:r>
@@ -6252,14 +5742,14 @@
       </p:sp>
       <p:sp>
         <p:nvSpPr>
-          <p:cNvPr id="8" name="Rounded Rectangle 7"/>
+          <p:cNvPr id="7" name="Rounded Rectangle 6"/>
           <p:cNvSpPr/>
           <p:nvPr/>
         </p:nvSpPr>
         <p:spPr>
           <a:xfrm>
-            <a:off x="6199632" y="1463040"/>
-            <a:ext cx="5257800" cy="4617720"/>
+            <a:off x="6199632" y="1417320"/>
+            <a:ext cx="5257800" cy="4709160"/>
           </a:xfrm>
           <a:prstGeom prst="roundRect">
             <a:avLst/>
@@ -6267,9 +5757,9 @@
           <a:solidFill>
             <a:srgbClr val="F8FAFC"/>
           </a:solidFill>
-          <a:ln w="12700">
+          <a:ln w="19050">
             <a:solidFill>
-              <a:srgbClr val="E2E8F0"/>
+              <a:srgbClr val="2563EB"/>
             </a:solidFill>
           </a:ln>
         </p:spPr>
@@ -6297,57 +5787,14 @@
       </p:sp>
       <p:sp>
         <p:nvSpPr>
-          <p:cNvPr id="9" name="Rectangle 8"/>
-          <p:cNvSpPr/>
-          <p:nvPr/>
-        </p:nvSpPr>
-        <p:spPr>
-          <a:xfrm>
-            <a:off x="6199632" y="1463040"/>
-            <a:ext cx="5257800" cy="73152"/>
-          </a:xfrm>
-          <a:prstGeom prst="rect">
-            <a:avLst/>
-          </a:prstGeom>
-          <a:solidFill>
-            <a:srgbClr val="2563EB"/>
-          </a:solidFill>
-          <a:ln>
-            <a:noFill/>
-          </a:ln>
-        </p:spPr>
-        <p:style>
-          <a:lnRef idx="1">
-            <a:schemeClr val="accent1"/>
-          </a:lnRef>
-          <a:fillRef idx="3">
-            <a:schemeClr val="accent1"/>
-          </a:fillRef>
-          <a:effectRef idx="2">
-            <a:schemeClr val="accent1"/>
-          </a:effectRef>
-          <a:fontRef idx="minor">
-            <a:schemeClr val="lt1"/>
-          </a:fontRef>
-        </p:style>
-        <p:txBody>
-          <a:bodyPr rtlCol="0" anchor="ctr"/>
-          <a:lstStyle/>
-          <a:p>
-            <a:pPr algn="ctr"/>
-          </a:p>
-        </p:txBody>
-      </p:sp>
-      <p:sp>
-        <p:nvSpPr>
-          <p:cNvPr id="10" name="TextBox 9"/>
+          <p:cNvPr id="8" name="TextBox 7"/>
           <p:cNvSpPr txBox="1"/>
           <p:nvPr/>
         </p:nvSpPr>
         <p:spPr>
           <a:xfrm>
-            <a:off x="6428232" y="1645920"/>
-            <a:ext cx="4800600" cy="4297680"/>
+            <a:off x="6565392" y="1691640"/>
+            <a:ext cx="4526280" cy="4251960"/>
           </a:xfrm>
           <a:prstGeom prst="rect">
             <a:avLst/>
@@ -6478,13 +5925,13 @@
       </p:sp>
       <p:sp>
         <p:nvSpPr>
-          <p:cNvPr id="11" name="Rectangle 10"/>
+          <p:cNvPr id="9" name="Rectangle 8"/>
           <p:cNvSpPr/>
           <p:nvPr/>
         </p:nvSpPr>
         <p:spPr>
           <a:xfrm>
-            <a:off x="731520" y="6309360"/>
+            <a:off x="731520" y="6327648"/>
             <a:ext cx="10728655" cy="13716"/>
           </a:xfrm>
           <a:prstGeom prst="rect">
@@ -6521,7 +5968,7 @@
       </p:sp>
       <p:sp>
         <p:nvSpPr>
-          <p:cNvPr id="12" name="TextBox 11"/>
+          <p:cNvPr id="10" name="TextBox 9"/>
           <p:cNvSpPr txBox="1"/>
           <p:nvPr/>
         </p:nvSpPr>
@@ -6640,8 +6087,8 @@
         </p:nvSpPr>
         <p:spPr>
           <a:xfrm>
-            <a:off x="731520" y="438912"/>
-            <a:ext cx="2926080" cy="292608"/>
+            <a:off x="731520" y="384048"/>
+            <a:ext cx="2743200" cy="274320"/>
           </a:xfrm>
           <a:prstGeom prst="roundRect">
             <a:avLst/>
@@ -6694,8 +6141,8 @@
         </p:nvSpPr>
         <p:spPr>
           <a:xfrm>
-            <a:off x="731520" y="804672"/>
-            <a:ext cx="10728655" cy="502920"/>
+            <a:off x="731520" y="713232"/>
+            <a:ext cx="10728655" cy="594360"/>
           </a:xfrm>
           <a:prstGeom prst="rect">
             <a:avLst/>
@@ -6752,8 +6199,8 @@
         </p:blipFill>
         <p:spPr>
           <a:xfrm>
-            <a:off x="10424160" y="438912"/>
-            <a:ext cx="1005840" cy="1005840"/>
+            <a:off x="10424160" y="384048"/>
+            <a:ext cx="1051560" cy="1051560"/>
           </a:xfrm>
           <a:prstGeom prst="rect">
             <a:avLst/>
@@ -6768,7 +6215,7 @@
         </p:nvSpPr>
         <p:spPr>
           <a:xfrm>
-            <a:off x="731520" y="1463040"/>
+            <a:off x="731520" y="1417320"/>
             <a:ext cx="2542032" cy="1463040"/>
           </a:xfrm>
           <a:prstGeom prst="roundRect">
@@ -6777,9 +6224,9 @@
           <a:solidFill>
             <a:srgbClr val="F8FAFC"/>
           </a:solidFill>
-          <a:ln w="12700">
+          <a:ln w="19050">
             <a:solidFill>
-              <a:srgbClr val="E2E8F0"/>
+              <a:srgbClr val="1E3A8A"/>
             </a:solidFill>
           </a:ln>
         </p:spPr>
@@ -6815,7 +6262,7 @@
           <a:p>
             <a:pPr>
               <a:spcBef>
-                <a:spcPts val="200"/>
+                <a:spcPts val="300"/>
               </a:spcBef>
             </a:pPr>
             <a:r>
@@ -6848,56 +6295,13 @@
       </p:sp>
       <p:sp>
         <p:nvSpPr>
-          <p:cNvPr id="7" name="Rectangle 6"/>
+          <p:cNvPr id="7" name="Rounded Rectangle 6"/>
           <p:cNvSpPr/>
           <p:nvPr/>
         </p:nvSpPr>
         <p:spPr>
           <a:xfrm>
-            <a:off x="731520" y="1463040"/>
-            <a:ext cx="2542032" cy="54864"/>
-          </a:xfrm>
-          <a:prstGeom prst="rect">
-            <a:avLst/>
-          </a:prstGeom>
-          <a:solidFill>
-            <a:srgbClr val="1E3A8A"/>
-          </a:solidFill>
-          <a:ln>
-            <a:noFill/>
-          </a:ln>
-        </p:spPr>
-        <p:style>
-          <a:lnRef idx="1">
-            <a:schemeClr val="accent1"/>
-          </a:lnRef>
-          <a:fillRef idx="3">
-            <a:schemeClr val="accent1"/>
-          </a:fillRef>
-          <a:effectRef idx="2">
-            <a:schemeClr val="accent1"/>
-          </a:effectRef>
-          <a:fontRef idx="minor">
-            <a:schemeClr val="lt1"/>
-          </a:fontRef>
-        </p:style>
-        <p:txBody>
-          <a:bodyPr rtlCol="0" anchor="ctr"/>
-          <a:lstStyle/>
-          <a:p>
-            <a:pPr algn="ctr"/>
-          </a:p>
-        </p:txBody>
-      </p:sp>
-      <p:sp>
-        <p:nvSpPr>
-          <p:cNvPr id="8" name="Rounded Rectangle 7"/>
-          <p:cNvSpPr/>
-          <p:nvPr/>
-        </p:nvSpPr>
-        <p:spPr>
-          <a:xfrm>
-            <a:off x="3456432" y="1463040"/>
+            <a:off x="3456432" y="1417320"/>
             <a:ext cx="2542032" cy="1463040"/>
           </a:xfrm>
           <a:prstGeom prst="roundRect">
@@ -6906,9 +6310,9 @@
           <a:solidFill>
             <a:srgbClr val="F8FAFC"/>
           </a:solidFill>
-          <a:ln w="12700">
+          <a:ln w="19050">
             <a:solidFill>
-              <a:srgbClr val="E2E8F0"/>
+              <a:srgbClr val="E11D48"/>
             </a:solidFill>
           </a:ln>
         </p:spPr>
@@ -6944,7 +6348,7 @@
           <a:p>
             <a:pPr>
               <a:spcBef>
-                <a:spcPts val="200"/>
+                <a:spcPts val="300"/>
               </a:spcBef>
             </a:pPr>
             <a:r>
@@ -6977,56 +6381,13 @@
       </p:sp>
       <p:sp>
         <p:nvSpPr>
-          <p:cNvPr id="9" name="Rectangle 8"/>
+          <p:cNvPr id="8" name="Rounded Rectangle 7"/>
           <p:cNvSpPr/>
           <p:nvPr/>
         </p:nvSpPr>
         <p:spPr>
           <a:xfrm>
-            <a:off x="3456432" y="1463040"/>
-            <a:ext cx="2542032" cy="54864"/>
-          </a:xfrm>
-          <a:prstGeom prst="rect">
-            <a:avLst/>
-          </a:prstGeom>
-          <a:solidFill>
-            <a:srgbClr val="E11D48"/>
-          </a:solidFill>
-          <a:ln>
-            <a:noFill/>
-          </a:ln>
-        </p:spPr>
-        <p:style>
-          <a:lnRef idx="1">
-            <a:schemeClr val="accent1"/>
-          </a:lnRef>
-          <a:fillRef idx="3">
-            <a:schemeClr val="accent1"/>
-          </a:fillRef>
-          <a:effectRef idx="2">
-            <a:schemeClr val="accent1"/>
-          </a:effectRef>
-          <a:fontRef idx="minor">
-            <a:schemeClr val="lt1"/>
-          </a:fontRef>
-        </p:style>
-        <p:txBody>
-          <a:bodyPr rtlCol="0" anchor="ctr"/>
-          <a:lstStyle/>
-          <a:p>
-            <a:pPr algn="ctr"/>
-          </a:p>
-        </p:txBody>
-      </p:sp>
-      <p:sp>
-        <p:nvSpPr>
-          <p:cNvPr id="10" name="Rounded Rectangle 9"/>
-          <p:cNvSpPr/>
-          <p:nvPr/>
-        </p:nvSpPr>
-        <p:spPr>
-          <a:xfrm>
-            <a:off x="6181344" y="1463040"/>
+            <a:off x="6181344" y="1417320"/>
             <a:ext cx="2542032" cy="1463040"/>
           </a:xfrm>
           <a:prstGeom prst="roundRect">
@@ -7035,9 +6396,9 @@
           <a:solidFill>
             <a:srgbClr val="F8FAFC"/>
           </a:solidFill>
-          <a:ln w="12700">
+          <a:ln w="19050">
             <a:solidFill>
-              <a:srgbClr val="E2E8F0"/>
+              <a:srgbClr val="059669"/>
             </a:solidFill>
           </a:ln>
         </p:spPr>
@@ -7073,7 +6434,7 @@
           <a:p>
             <a:pPr>
               <a:spcBef>
-                <a:spcPts val="200"/>
+                <a:spcPts val="300"/>
               </a:spcBef>
             </a:pPr>
             <a:r>
@@ -7106,56 +6467,13 @@
       </p:sp>
       <p:sp>
         <p:nvSpPr>
-          <p:cNvPr id="11" name="Rectangle 10"/>
+          <p:cNvPr id="9" name="Rounded Rectangle 8"/>
           <p:cNvSpPr/>
           <p:nvPr/>
         </p:nvSpPr>
         <p:spPr>
           <a:xfrm>
-            <a:off x="6181344" y="1463040"/>
-            <a:ext cx="2542032" cy="54864"/>
-          </a:xfrm>
-          <a:prstGeom prst="rect">
-            <a:avLst/>
-          </a:prstGeom>
-          <a:solidFill>
-            <a:srgbClr val="059669"/>
-          </a:solidFill>
-          <a:ln>
-            <a:noFill/>
-          </a:ln>
-        </p:spPr>
-        <p:style>
-          <a:lnRef idx="1">
-            <a:schemeClr val="accent1"/>
-          </a:lnRef>
-          <a:fillRef idx="3">
-            <a:schemeClr val="accent1"/>
-          </a:fillRef>
-          <a:effectRef idx="2">
-            <a:schemeClr val="accent1"/>
-          </a:effectRef>
-          <a:fontRef idx="minor">
-            <a:schemeClr val="lt1"/>
-          </a:fontRef>
-        </p:style>
-        <p:txBody>
-          <a:bodyPr rtlCol="0" anchor="ctr"/>
-          <a:lstStyle/>
-          <a:p>
-            <a:pPr algn="ctr"/>
-          </a:p>
-        </p:txBody>
-      </p:sp>
-      <p:sp>
-        <p:nvSpPr>
-          <p:cNvPr id="12" name="Rounded Rectangle 11"/>
-          <p:cNvSpPr/>
-          <p:nvPr/>
-        </p:nvSpPr>
-        <p:spPr>
-          <a:xfrm>
-            <a:off x="8906256" y="1463040"/>
+            <a:off x="8906256" y="1417320"/>
             <a:ext cx="2542032" cy="1463040"/>
           </a:xfrm>
           <a:prstGeom prst="roundRect">
@@ -7164,9 +6482,9 @@
           <a:solidFill>
             <a:srgbClr val="F8FAFC"/>
           </a:solidFill>
-          <a:ln w="12700">
+          <a:ln w="19050">
             <a:solidFill>
-              <a:srgbClr val="E2E8F0"/>
+              <a:srgbClr val="D97706"/>
             </a:solidFill>
           </a:ln>
         </p:spPr>
@@ -7202,7 +6520,7 @@
           <a:p>
             <a:pPr>
               <a:spcBef>
-                <a:spcPts val="200"/>
+                <a:spcPts val="300"/>
               </a:spcBef>
             </a:pPr>
             <a:r>
@@ -7235,57 +6553,14 @@
       </p:sp>
       <p:sp>
         <p:nvSpPr>
-          <p:cNvPr id="13" name="Rectangle 12"/>
+          <p:cNvPr id="10" name="Rounded Rectangle 9"/>
           <p:cNvSpPr/>
           <p:nvPr/>
         </p:nvSpPr>
         <p:spPr>
           <a:xfrm>
-            <a:off x="8906256" y="1463040"/>
-            <a:ext cx="2542032" cy="54864"/>
-          </a:xfrm>
-          <a:prstGeom prst="rect">
-            <a:avLst/>
-          </a:prstGeom>
-          <a:solidFill>
-            <a:srgbClr val="D97706"/>
-          </a:solidFill>
-          <a:ln>
-            <a:noFill/>
-          </a:ln>
-        </p:spPr>
-        <p:style>
-          <a:lnRef idx="1">
-            <a:schemeClr val="accent1"/>
-          </a:lnRef>
-          <a:fillRef idx="3">
-            <a:schemeClr val="accent1"/>
-          </a:fillRef>
-          <a:effectRef idx="2">
-            <a:schemeClr val="accent1"/>
-          </a:effectRef>
-          <a:fontRef idx="minor">
-            <a:schemeClr val="lt1"/>
-          </a:fontRef>
-        </p:style>
-        <p:txBody>
-          <a:bodyPr rtlCol="0" anchor="ctr"/>
-          <a:lstStyle/>
-          <a:p>
-            <a:pPr algn="ctr"/>
-          </a:p>
-        </p:txBody>
-      </p:sp>
-      <p:sp>
-        <p:nvSpPr>
-          <p:cNvPr id="14" name="Rounded Rectangle 13"/>
-          <p:cNvSpPr/>
-          <p:nvPr/>
-        </p:nvSpPr>
-        <p:spPr>
-          <a:xfrm>
             <a:off x="731520" y="3063240"/>
-            <a:ext cx="3456432" cy="2057400"/>
+            <a:ext cx="3456432" cy="2148840"/>
           </a:xfrm>
           <a:prstGeom prst="roundRect">
             <a:avLst/>
@@ -7293,9 +6568,9 @@
           <a:solidFill>
             <a:srgbClr val="F8FAFC"/>
           </a:solidFill>
-          <a:ln w="12700">
+          <a:ln w="19050">
             <a:solidFill>
-              <a:srgbClr val="E2E8F0"/>
+              <a:srgbClr val="1E3A8A"/>
             </a:solidFill>
           </a:ln>
         </p:spPr>
@@ -7314,7 +6589,7 @@
           </a:fontRef>
         </p:style>
         <p:txBody>
-          <a:bodyPr rtlCol="0" anchor="ctr" wrap="square" lIns="182880" tIns="164592" rIns="182880" bIns="137160"/>
+          <a:bodyPr rtlCol="0" anchor="ctr" wrap="square" lIns="182880" tIns="182880" rIns="182880" bIns="137160"/>
           <a:lstStyle/>
           <a:p>
             <a:pPr algn="ctr"/>
@@ -7348,57 +6623,14 @@
       </p:sp>
       <p:sp>
         <p:nvSpPr>
-          <p:cNvPr id="15" name="Rectangle 14"/>
+          <p:cNvPr id="11" name="Rounded Rectangle 10"/>
           <p:cNvSpPr/>
           <p:nvPr/>
         </p:nvSpPr>
         <p:spPr>
           <a:xfrm>
-            <a:off x="731520" y="3063240"/>
-            <a:ext cx="3456432" cy="54864"/>
-          </a:xfrm>
-          <a:prstGeom prst="rect">
-            <a:avLst/>
-          </a:prstGeom>
-          <a:solidFill>
-            <a:srgbClr val="1E3A8A"/>
-          </a:solidFill>
-          <a:ln>
-            <a:noFill/>
-          </a:ln>
-        </p:spPr>
-        <p:style>
-          <a:lnRef idx="1">
-            <a:schemeClr val="accent1"/>
-          </a:lnRef>
-          <a:fillRef idx="3">
-            <a:schemeClr val="accent1"/>
-          </a:fillRef>
-          <a:effectRef idx="2">
-            <a:schemeClr val="accent1"/>
-          </a:effectRef>
-          <a:fontRef idx="minor">
-            <a:schemeClr val="lt1"/>
-          </a:fontRef>
-        </p:style>
-        <p:txBody>
-          <a:bodyPr rtlCol="0" anchor="ctr"/>
-          <a:lstStyle/>
-          <a:p>
-            <a:pPr algn="ctr"/>
-          </a:p>
-        </p:txBody>
-      </p:sp>
-      <p:sp>
-        <p:nvSpPr>
-          <p:cNvPr id="16" name="Rounded Rectangle 15"/>
-          <p:cNvSpPr/>
-          <p:nvPr/>
-        </p:nvSpPr>
-        <p:spPr>
-          <a:xfrm>
             <a:off x="4370832" y="3063240"/>
-            <a:ext cx="3456432" cy="2057400"/>
+            <a:ext cx="3456432" cy="2148840"/>
           </a:xfrm>
           <a:prstGeom prst="roundRect">
             <a:avLst/>
@@ -7406,9 +6638,9 @@
           <a:solidFill>
             <a:srgbClr val="F8FAFC"/>
           </a:solidFill>
-          <a:ln w="12700">
+          <a:ln w="19050">
             <a:solidFill>
-              <a:srgbClr val="E2E8F0"/>
+              <a:srgbClr val="2563EB"/>
             </a:solidFill>
           </a:ln>
         </p:spPr>
@@ -7427,7 +6659,7 @@
           </a:fontRef>
         </p:style>
         <p:txBody>
-          <a:bodyPr rtlCol="0" anchor="ctr" wrap="square" lIns="182880" tIns="164592" rIns="182880" bIns="137160"/>
+          <a:bodyPr rtlCol="0" anchor="ctr" wrap="square" lIns="182880" tIns="182880" rIns="182880" bIns="137160"/>
           <a:lstStyle/>
           <a:p>
             <a:pPr algn="ctr"/>
@@ -7461,57 +6693,14 @@
       </p:sp>
       <p:sp>
         <p:nvSpPr>
-          <p:cNvPr id="17" name="Rectangle 16"/>
+          <p:cNvPr id="12" name="Rounded Rectangle 11"/>
           <p:cNvSpPr/>
           <p:nvPr/>
         </p:nvSpPr>
         <p:spPr>
           <a:xfrm>
-            <a:off x="4370832" y="3063240"/>
-            <a:ext cx="3456432" cy="54864"/>
-          </a:xfrm>
-          <a:prstGeom prst="rect">
-            <a:avLst/>
-          </a:prstGeom>
-          <a:solidFill>
-            <a:srgbClr val="2563EB"/>
-          </a:solidFill>
-          <a:ln>
-            <a:noFill/>
-          </a:ln>
-        </p:spPr>
-        <p:style>
-          <a:lnRef idx="1">
-            <a:schemeClr val="accent1"/>
-          </a:lnRef>
-          <a:fillRef idx="3">
-            <a:schemeClr val="accent1"/>
-          </a:fillRef>
-          <a:effectRef idx="2">
-            <a:schemeClr val="accent1"/>
-          </a:effectRef>
-          <a:fontRef idx="minor">
-            <a:schemeClr val="lt1"/>
-          </a:fontRef>
-        </p:style>
-        <p:txBody>
-          <a:bodyPr rtlCol="0" anchor="ctr"/>
-          <a:lstStyle/>
-          <a:p>
-            <a:pPr algn="ctr"/>
-          </a:p>
-        </p:txBody>
-      </p:sp>
-      <p:sp>
-        <p:nvSpPr>
-          <p:cNvPr id="18" name="Rounded Rectangle 17"/>
-          <p:cNvSpPr/>
-          <p:nvPr/>
-        </p:nvSpPr>
-        <p:spPr>
-          <a:xfrm>
             <a:off x="8010144" y="3063240"/>
-            <a:ext cx="3456432" cy="2057400"/>
+            <a:ext cx="3456432" cy="2148840"/>
           </a:xfrm>
           <a:prstGeom prst="roundRect">
             <a:avLst/>
@@ -7519,9 +6708,9 @@
           <a:solidFill>
             <a:srgbClr val="F8FAFC"/>
           </a:solidFill>
-          <a:ln w="12700">
+          <a:ln w="19050">
             <a:solidFill>
-              <a:srgbClr val="E2E8F0"/>
+              <a:srgbClr val="059669"/>
             </a:solidFill>
           </a:ln>
         </p:spPr>
@@ -7540,7 +6729,7 @@
           </a:fontRef>
         </p:style>
         <p:txBody>
-          <a:bodyPr rtlCol="0" anchor="ctr" wrap="square" lIns="182880" tIns="164592" rIns="182880" bIns="137160"/>
+          <a:bodyPr rtlCol="0" anchor="ctr" wrap="square" lIns="182880" tIns="182880" rIns="182880" bIns="137160"/>
           <a:lstStyle/>
           <a:p>
             <a:pPr algn="ctr"/>
@@ -7574,57 +6763,14 @@
       </p:sp>
       <p:sp>
         <p:nvSpPr>
-          <p:cNvPr id="19" name="Rectangle 18"/>
+          <p:cNvPr id="13" name="Rounded Rectangle 12"/>
           <p:cNvSpPr/>
           <p:nvPr/>
         </p:nvSpPr>
         <p:spPr>
           <a:xfrm>
-            <a:off x="8010144" y="3063240"/>
-            <a:ext cx="3456432" cy="54864"/>
-          </a:xfrm>
-          <a:prstGeom prst="rect">
-            <a:avLst/>
-          </a:prstGeom>
-          <a:solidFill>
-            <a:srgbClr val="059669"/>
-          </a:solidFill>
-          <a:ln>
-            <a:noFill/>
-          </a:ln>
-        </p:spPr>
-        <p:style>
-          <a:lnRef idx="1">
-            <a:schemeClr val="accent1"/>
-          </a:lnRef>
-          <a:fillRef idx="3">
-            <a:schemeClr val="accent1"/>
-          </a:fillRef>
-          <a:effectRef idx="2">
-            <a:schemeClr val="accent1"/>
-          </a:effectRef>
-          <a:fontRef idx="minor">
-            <a:schemeClr val="lt1"/>
-          </a:fontRef>
-        </p:style>
-        <p:txBody>
-          <a:bodyPr rtlCol="0" anchor="ctr"/>
-          <a:lstStyle/>
-          <a:p>
-            <a:pPr algn="ctr"/>
-          </a:p>
-        </p:txBody>
-      </p:sp>
-      <p:sp>
-        <p:nvSpPr>
-          <p:cNvPr id="20" name="Rounded Rectangle 19"/>
-          <p:cNvSpPr/>
-          <p:nvPr/>
-        </p:nvSpPr>
-        <p:spPr>
-          <a:xfrm>
-            <a:off x="731520" y="5257800"/>
-            <a:ext cx="10728655" cy="868680"/>
+            <a:off x="731520" y="5394960"/>
+            <a:ext cx="10728655" cy="777240"/>
           </a:xfrm>
           <a:prstGeom prst="roundRect">
             <a:avLst/>
@@ -7653,12 +6799,12 @@
           </a:fontRef>
         </p:style>
         <p:txBody>
-          <a:bodyPr rtlCol="0" anchor="ctr" wrap="square" lIns="228600" tIns="109728" rIns="228600" bIns="91440"/>
+          <a:bodyPr rtlCol="0" anchor="ctr" wrap="square" lIns="228600" tIns="109728" rIns="228600" bIns="73152"/>
           <a:lstStyle/>
           <a:p>
             <a:pPr algn="ctr"/>
             <a:r>
-              <a:rPr sz="1000" b="1">
+              <a:rPr sz="950" b="1">
                 <a:solidFill>
                   <a:srgbClr val="1E3A8A"/>
                 </a:solidFill>
@@ -7670,11 +6816,11 @@
           <a:p>
             <a:pPr>
               <a:spcBef>
-                <a:spcPts val="400"/>
+                <a:spcPts val="300"/>
               </a:spcBef>
             </a:pPr>
             <a:r>
-              <a:rPr sz="900" b="1">
+              <a:rPr sz="850" b="1">
                 <a:solidFill>
                   <a:srgbClr val="2563EB"/>
                 </a:solidFill>
@@ -7687,13 +6833,13 @@
       </p:sp>
       <p:sp>
         <p:nvSpPr>
-          <p:cNvPr id="21" name="Rectangle 20"/>
+          <p:cNvPr id="14" name="Rectangle 13"/>
           <p:cNvSpPr/>
           <p:nvPr/>
         </p:nvSpPr>
         <p:spPr>
           <a:xfrm>
-            <a:off x="731520" y="6309360"/>
+            <a:off x="731520" y="6327648"/>
             <a:ext cx="10728655" cy="13716"/>
           </a:xfrm>
           <a:prstGeom prst="rect">
@@ -7730,7 +6876,7 @@
       </p:sp>
       <p:sp>
         <p:nvSpPr>
-          <p:cNvPr id="22" name="TextBox 21"/>
+          <p:cNvPr id="15" name="TextBox 14"/>
           <p:cNvSpPr txBox="1"/>
           <p:nvPr/>
         </p:nvSpPr>

</xml_diff>